<commit_message>
feat: update 8-slide PowerPoint presentation matching reference slide designs
</commit_message>
<xml_diff>
--- a/public/GreenVerse_AI_IoT_Smart_Campus_Presentation.pptx
+++ b/public/GreenVerse_AI_IoT_Smart_Campus_Presentation.pptx
@@ -13,10 +13,6 @@
     <p:sldId id="261" r:id="rId12"/>
     <p:sldId id="262" r:id="rId13"/>
     <p:sldId id="263" r:id="rId14"/>
-    <p:sldId id="264" r:id="rId15"/>
-    <p:sldId id="265" r:id="rId16"/>
-    <p:sldId id="266" r:id="rId17"/>
-    <p:sldId id="267" r:id="rId18"/>
   </p:sldIdLst>
   <p:sldSz cx="12191695" cy="6858000" type="screen4x3"/>
   <p:notesSz cx="6858000" cy="9144000"/>
@@ -3191,7 +3187,7 @@
               <a:spcBef>
                 <a:spcPts val="800"/>
               </a:spcBef>
-              <a:defRPr sz="2200" b="1">
+              <a:defRPr sz="2000" b="1">
                 <a:solidFill>
                   <a:srgbClr val="FFFFFF"/>
                 </a:solidFill>
@@ -3199,7 +3195,7 @@
               </a:defRPr>
             </a:pPr>
             <a:r>
-              <a:t>AI-IoT Smart Campus Sustainability System</a:t>
+              <a:t>AI-IoT Smart Campus Sustainability &amp; Maintenance Platform</a:t>
             </a:r>
           </a:p>
           <a:p>
@@ -3215,7 +3211,7 @@
               </a:defRPr>
             </a:pPr>
             <a:r>
-              <a:t>Empowering Educational Institutions with Artificial Intelligence, IoT Telemetry, GIS Mapping &amp; Renewable Energy</a:t>
+              <a:t>Transforming Educational Institutions with Artificial Intelligence, IoT Telemetry, GIS Mapping &amp; Renewable Energy</a:t>
             </a:r>
           </a:p>
         </p:txBody>
@@ -3423,1141 +3419,6 @@
           <a:xfrm>
             <a:off x="7223760" y="822960"/>
             <a:ext cx="4114800" cy="5212080"/>
-          </a:xfrm>
-          <a:prstGeom prst="rect">
-            <a:avLst/>
-          </a:prstGeom>
-        </p:spPr>
-      </p:pic>
-    </p:spTree>
-  </p:cSld>
-  <p:clrMapOvr>
-    <a:masterClrMapping/>
-  </p:clrMapOvr>
-</p:sld>
-</file>
-
-<file path=ppt/slides/slide10.xml><?xml version="1.0" encoding="utf-8"?>
-<p:sld xmlns:a="http://schemas.openxmlformats.org/drawingml/2006/main" xmlns:p="http://schemas.openxmlformats.org/presentationml/2006/main" xmlns:r="http://schemas.openxmlformats.org/officeDocument/2006/relationships">
-  <p:cSld>
-    <p:bg>
-      <p:bgPr>
-        <a:solidFill>
-          <a:srgbClr val="071A12"/>
-        </a:solidFill>
-        <a:effectLst/>
-      </p:bgPr>
-    </p:bg>
-    <p:spTree>
-      <p:nvGrpSpPr>
-        <p:cNvPr id="1" name=""/>
-        <p:cNvGrpSpPr/>
-        <p:nvPr/>
-      </p:nvGrpSpPr>
-      <p:grpSpPr/>
-      <p:sp>
-        <p:nvSpPr>
-          <p:cNvPr id="2" name="TextBox 1"/>
-          <p:cNvSpPr txBox="1"/>
-          <p:nvPr/>
-        </p:nvSpPr>
-        <p:spPr>
-          <a:xfrm>
-            <a:off x="731520" y="365760"/>
-            <a:ext cx="10728655" cy="914400"/>
-          </a:xfrm>
-          <a:prstGeom prst="rect">
-            <a:avLst/>
-          </a:prstGeom>
-          <a:noFill/>
-        </p:spPr>
-        <p:txBody>
-          <a:bodyPr wrap="square" lIns="0" tIns="0" rIns="0" bIns="0">
-            <a:spAutoFit/>
-          </a:bodyPr>
-          <a:lstStyle/>
-          <a:p>
-            <a:pPr>
-              <a:defRPr sz="2800" b="1">
-                <a:solidFill>
-                  <a:srgbClr val="FFFFFF"/>
-                </a:solidFill>
-                <a:latin typeface="Poppins"/>
-              </a:defRPr>
-            </a:pPr>
-            <a:r>
-              <a:t>FUTURE SCOPE &amp; DEPLOYMENT ROADMAP</a:t>
-            </a:r>
-          </a:p>
-          <a:p>
-            <a:pPr>
-              <a:spcBef>
-                <a:spcPts val="400"/>
-              </a:spcBef>
-              <a:defRPr sz="1300">
-                <a:solidFill>
-                  <a:srgbClr val="00E5FF"/>
-                </a:solidFill>
-                <a:latin typeface="Inter"/>
-              </a:defRPr>
-            </a:pPr>
-            <a:r>
-              <a:t>Strategic Growth Path from SPNREC Pilot to National Network</a:t>
-            </a:r>
-          </a:p>
-        </p:txBody>
-      </p:sp>
-      <p:sp>
-        <p:nvSpPr>
-          <p:cNvPr id="3" name="Rounded Rectangle 2"/>
-          <p:cNvSpPr/>
-          <p:nvPr/>
-        </p:nvSpPr>
-        <p:spPr>
-          <a:xfrm>
-            <a:off x="731520" y="2011680"/>
-            <a:ext cx="2011680" cy="3474720"/>
-          </a:xfrm>
-          <a:prstGeom prst="roundRect">
-            <a:avLst/>
-          </a:prstGeom>
-          <a:solidFill>
-            <a:srgbClr val="0E2A1F"/>
-          </a:solidFill>
-          <a:ln w="19050">
-            <a:solidFill>
-              <a:srgbClr val="00C853"/>
-            </a:solidFill>
-          </a:ln>
-        </p:spPr>
-        <p:style>
-          <a:lnRef idx="1">
-            <a:schemeClr val="accent1"/>
-          </a:lnRef>
-          <a:fillRef idx="3">
-            <a:schemeClr val="accent1"/>
-          </a:fillRef>
-          <a:effectRef idx="2">
-            <a:schemeClr val="accent1"/>
-          </a:effectRef>
-          <a:fontRef idx="minor">
-            <a:schemeClr val="lt1"/>
-          </a:fontRef>
-        </p:style>
-        <p:txBody>
-          <a:bodyPr rtlCol="0" anchor="ctr" wrap="square" lIns="182880" tIns="182880"/>
-          <a:lstStyle/>
-          <a:p>
-            <a:pPr algn="ctr">
-              <a:defRPr sz="2400" b="1">
-                <a:solidFill>
-                  <a:srgbClr val="00E5FF"/>
-                </a:solidFill>
-                <a:latin typeface="Montserrat"/>
-              </a:defRPr>
-            </a:pPr>
-            <a:r>
-              <a:t>2026</a:t>
-            </a:r>
-          </a:p>
-          <a:p>
-            <a:pPr>
-              <a:spcBef>
-                <a:spcPts val="1400"/>
-              </a:spcBef>
-              <a:defRPr sz="1300" b="1">
-                <a:solidFill>
-                  <a:srgbClr val="FFFFFF"/>
-                </a:solidFill>
-                <a:latin typeface="Poppins"/>
-              </a:defRPr>
-            </a:pPr>
-            <a:r>
-              <a:t>AI Prediction &amp; SPNREC Pilot</a:t>
-            </a:r>
-          </a:p>
-        </p:txBody>
-      </p:sp>
-      <p:sp>
-        <p:nvSpPr>
-          <p:cNvPr id="4" name="Rounded Rectangle 3"/>
-          <p:cNvSpPr/>
-          <p:nvPr/>
-        </p:nvSpPr>
-        <p:spPr>
-          <a:xfrm>
-            <a:off x="2907791" y="2011680"/>
-            <a:ext cx="2011680" cy="3474720"/>
-          </a:xfrm>
-          <a:prstGeom prst="roundRect">
-            <a:avLst/>
-          </a:prstGeom>
-          <a:solidFill>
-            <a:srgbClr val="0E2A1F"/>
-          </a:solidFill>
-          <a:ln w="19050">
-            <a:solidFill>
-              <a:srgbClr val="00C853"/>
-            </a:solidFill>
-          </a:ln>
-        </p:spPr>
-        <p:style>
-          <a:lnRef idx="1">
-            <a:schemeClr val="accent1"/>
-          </a:lnRef>
-          <a:fillRef idx="3">
-            <a:schemeClr val="accent1"/>
-          </a:fillRef>
-          <a:effectRef idx="2">
-            <a:schemeClr val="accent1"/>
-          </a:effectRef>
-          <a:fontRef idx="minor">
-            <a:schemeClr val="lt1"/>
-          </a:fontRef>
-        </p:style>
-        <p:txBody>
-          <a:bodyPr rtlCol="0" anchor="ctr" wrap="square" lIns="182880" tIns="182880"/>
-          <a:lstStyle/>
-          <a:p>
-            <a:pPr algn="ctr">
-              <a:defRPr sz="2400" b="1">
-                <a:solidFill>
-                  <a:srgbClr val="00E5FF"/>
-                </a:solidFill>
-                <a:latin typeface="Montserrat"/>
-              </a:defRPr>
-            </a:pPr>
-            <a:r>
-              <a:t>2027</a:t>
-            </a:r>
-          </a:p>
-          <a:p>
-            <a:pPr>
-              <a:spcBef>
-                <a:spcPts val="1400"/>
-              </a:spcBef>
-              <a:defRPr sz="1300" b="1">
-                <a:solidFill>
-                  <a:srgbClr val="FFFFFF"/>
-                </a:solidFill>
-                <a:latin typeface="Poppins"/>
-              </a:defRPr>
-            </a:pPr>
-            <a:r>
-              <a:t>Computer Vision &amp; District Colleges</a:t>
-            </a:r>
-          </a:p>
-        </p:txBody>
-      </p:sp>
-      <p:sp>
-        <p:nvSpPr>
-          <p:cNvPr id="5" name="Rounded Rectangle 4"/>
-          <p:cNvSpPr/>
-          <p:nvPr/>
-        </p:nvSpPr>
-        <p:spPr>
-          <a:xfrm>
-            <a:off x="5084064" y="2011680"/>
-            <a:ext cx="2011680" cy="3474720"/>
-          </a:xfrm>
-          <a:prstGeom prst="roundRect">
-            <a:avLst/>
-          </a:prstGeom>
-          <a:solidFill>
-            <a:srgbClr val="0E2A1F"/>
-          </a:solidFill>
-          <a:ln w="19050">
-            <a:solidFill>
-              <a:srgbClr val="00C853"/>
-            </a:solidFill>
-          </a:ln>
-        </p:spPr>
-        <p:style>
-          <a:lnRef idx="1">
-            <a:schemeClr val="accent1"/>
-          </a:lnRef>
-          <a:fillRef idx="3">
-            <a:schemeClr val="accent1"/>
-          </a:fillRef>
-          <a:effectRef idx="2">
-            <a:schemeClr val="accent1"/>
-          </a:effectRef>
-          <a:fontRef idx="minor">
-            <a:schemeClr val="lt1"/>
-          </a:fontRef>
-        </p:style>
-        <p:txBody>
-          <a:bodyPr rtlCol="0" anchor="ctr" wrap="square" lIns="182880" tIns="182880"/>
-          <a:lstStyle/>
-          <a:p>
-            <a:pPr algn="ctr">
-              <a:defRPr sz="2400" b="1">
-                <a:solidFill>
-                  <a:srgbClr val="00E5FF"/>
-                </a:solidFill>
-                <a:latin typeface="Montserrat"/>
-              </a:defRPr>
-            </a:pPr>
-            <a:r>
-              <a:t>2028</a:t>
-            </a:r>
-          </a:p>
-          <a:p>
-            <a:pPr>
-              <a:spcBef>
-                <a:spcPts val="1400"/>
-              </a:spcBef>
-              <a:defRPr sz="1300" b="1">
-                <a:solidFill>
-                  <a:srgbClr val="FFFFFF"/>
-                </a:solidFill>
-                <a:latin typeface="Poppins"/>
-              </a:defRPr>
-            </a:pPr>
-            <a:r>
-              <a:t>Autonomous Drone Campus Inspection</a:t>
-            </a:r>
-          </a:p>
-        </p:txBody>
-      </p:sp>
-      <p:sp>
-        <p:nvSpPr>
-          <p:cNvPr id="6" name="Rounded Rectangle 5"/>
-          <p:cNvSpPr/>
-          <p:nvPr/>
-        </p:nvSpPr>
-        <p:spPr>
-          <a:xfrm>
-            <a:off x="7260336" y="2011680"/>
-            <a:ext cx="2011680" cy="3474720"/>
-          </a:xfrm>
-          <a:prstGeom prst="roundRect">
-            <a:avLst/>
-          </a:prstGeom>
-          <a:solidFill>
-            <a:srgbClr val="0E2A1F"/>
-          </a:solidFill>
-          <a:ln w="19050">
-            <a:solidFill>
-              <a:srgbClr val="00C853"/>
-            </a:solidFill>
-          </a:ln>
-        </p:spPr>
-        <p:style>
-          <a:lnRef idx="1">
-            <a:schemeClr val="accent1"/>
-          </a:lnRef>
-          <a:fillRef idx="3">
-            <a:schemeClr val="accent1"/>
-          </a:fillRef>
-          <a:effectRef idx="2">
-            <a:schemeClr val="accent1"/>
-          </a:effectRef>
-          <a:fontRef idx="minor">
-            <a:schemeClr val="lt1"/>
-          </a:fontRef>
-        </p:style>
-        <p:txBody>
-          <a:bodyPr rtlCol="0" anchor="ctr" wrap="square" lIns="182880" tIns="182880"/>
-          <a:lstStyle/>
-          <a:p>
-            <a:pPr algn="ctr">
-              <a:defRPr sz="2400" b="1">
-                <a:solidFill>
-                  <a:srgbClr val="00E5FF"/>
-                </a:solidFill>
-                <a:latin typeface="Montserrat"/>
-              </a:defRPr>
-            </a:pPr>
-            <a:r>
-              <a:t>2029</a:t>
-            </a:r>
-          </a:p>
-          <a:p>
-            <a:pPr>
-              <a:spcBef>
-                <a:spcPts val="1400"/>
-              </a:spcBef>
-              <a:defRPr sz="1300" b="1">
-                <a:solidFill>
-                  <a:srgbClr val="FFFFFF"/>
-                </a:solidFill>
-                <a:latin typeface="Poppins"/>
-              </a:defRPr>
-            </a:pPr>
-            <a:r>
-              <a:t>Digital Twin Campus Simulation</a:t>
-            </a:r>
-          </a:p>
-        </p:txBody>
-      </p:sp>
-      <p:sp>
-        <p:nvSpPr>
-          <p:cNvPr id="7" name="Rounded Rectangle 6"/>
-          <p:cNvSpPr/>
-          <p:nvPr/>
-        </p:nvSpPr>
-        <p:spPr>
-          <a:xfrm>
-            <a:off x="9436608" y="2011680"/>
-            <a:ext cx="2011680" cy="3474720"/>
-          </a:xfrm>
-          <a:prstGeom prst="roundRect">
-            <a:avLst/>
-          </a:prstGeom>
-          <a:solidFill>
-            <a:srgbClr val="0E2A1F"/>
-          </a:solidFill>
-          <a:ln w="19050">
-            <a:solidFill>
-              <a:srgbClr val="00C853"/>
-            </a:solidFill>
-          </a:ln>
-        </p:spPr>
-        <p:style>
-          <a:lnRef idx="1">
-            <a:schemeClr val="accent1"/>
-          </a:lnRef>
-          <a:fillRef idx="3">
-            <a:schemeClr val="accent1"/>
-          </a:fillRef>
-          <a:effectRef idx="2">
-            <a:schemeClr val="accent1"/>
-          </a:effectRef>
-          <a:fontRef idx="minor">
-            <a:schemeClr val="lt1"/>
-          </a:fontRef>
-        </p:style>
-        <p:txBody>
-          <a:bodyPr rtlCol="0" anchor="ctr" wrap="square" lIns="182880" tIns="182880"/>
-          <a:lstStyle/>
-          <a:p>
-            <a:pPr algn="ctr">
-              <a:defRPr sz="2400" b="1">
-                <a:solidFill>
-                  <a:srgbClr val="00E5FF"/>
-                </a:solidFill>
-                <a:latin typeface="Montserrat"/>
-              </a:defRPr>
-            </a:pPr>
-            <a:r>
-              <a:t>2030</a:t>
-            </a:r>
-          </a:p>
-          <a:p>
-            <a:pPr>
-              <a:spcBef>
-                <a:spcPts val="1400"/>
-              </a:spcBef>
-              <a:defRPr sz="1300" b="1">
-                <a:solidFill>
-                  <a:srgbClr val="FFFFFF"/>
-                </a:solidFill>
-                <a:latin typeface="Poppins"/>
-              </a:defRPr>
-            </a:pPr>
-            <a:r>
-              <a:t>National Net-Zero Campus Mesh</a:t>
-            </a:r>
-          </a:p>
-        </p:txBody>
-      </p:sp>
-    </p:spTree>
-  </p:cSld>
-  <p:clrMapOvr>
-    <a:masterClrMapping/>
-  </p:clrMapOvr>
-</p:sld>
-</file>
-
-<file path=ppt/slides/slide11.xml><?xml version="1.0" encoding="utf-8"?>
-<p:sld xmlns:a="http://schemas.openxmlformats.org/drawingml/2006/main" xmlns:p="http://schemas.openxmlformats.org/presentationml/2006/main" xmlns:r="http://schemas.openxmlformats.org/officeDocument/2006/relationships">
-  <p:cSld>
-    <p:bg>
-      <p:bgPr>
-        <a:solidFill>
-          <a:srgbClr val="071A12"/>
-        </a:solidFill>
-        <a:effectLst/>
-      </p:bgPr>
-    </p:bg>
-    <p:spTree>
-      <p:nvGrpSpPr>
-        <p:cNvPr id="1" name=""/>
-        <p:cNvGrpSpPr/>
-        <p:nvPr/>
-      </p:nvGrpSpPr>
-      <p:grpSpPr/>
-      <p:sp>
-        <p:nvSpPr>
-          <p:cNvPr id="2" name="TextBox 1"/>
-          <p:cNvSpPr txBox="1"/>
-          <p:nvPr/>
-        </p:nvSpPr>
-        <p:spPr>
-          <a:xfrm>
-            <a:off x="731520" y="365760"/>
-            <a:ext cx="10728655" cy="914400"/>
-          </a:xfrm>
-          <a:prstGeom prst="rect">
-            <a:avLst/>
-          </a:prstGeom>
-          <a:noFill/>
-        </p:spPr>
-        <p:txBody>
-          <a:bodyPr wrap="square" lIns="0" tIns="0" rIns="0" bIns="0">
-            <a:spAutoFit/>
-          </a:bodyPr>
-          <a:lstStyle/>
-          <a:p>
-            <a:pPr>
-              <a:defRPr sz="2800" b="1">
-                <a:solidFill>
-                  <a:srgbClr val="FFFFFF"/>
-                </a:solidFill>
-                <a:latin typeface="Poppins"/>
-              </a:defRPr>
-            </a:pPr>
-            <a:r>
-              <a:t>MULTI-DIMENSIONAL IMPACT MATRIX</a:t>
-            </a:r>
-          </a:p>
-          <a:p>
-            <a:pPr>
-              <a:spcBef>
-                <a:spcPts val="400"/>
-              </a:spcBef>
-              <a:defRPr sz="1300">
-                <a:solidFill>
-                  <a:srgbClr val="00E5FF"/>
-                </a:solidFill>
-                <a:latin typeface="Inter"/>
-              </a:defRPr>
-            </a:pPr>
-            <a:r>
-              <a:t>Transforming Educational Institutions Across Key Sectors</a:t>
-            </a:r>
-          </a:p>
-        </p:txBody>
-      </p:sp>
-      <p:sp>
-        <p:nvSpPr>
-          <p:cNvPr id="3" name="Rounded Rectangle 2"/>
-          <p:cNvSpPr/>
-          <p:nvPr/>
-        </p:nvSpPr>
-        <p:spPr>
-          <a:xfrm>
-            <a:off x="731520" y="1645920"/>
-            <a:ext cx="3383280" cy="2011680"/>
-          </a:xfrm>
-          <a:prstGeom prst="roundRect">
-            <a:avLst/>
-          </a:prstGeom>
-          <a:solidFill>
-            <a:srgbClr val="0E2A1F"/>
-          </a:solidFill>
-          <a:ln w="19050">
-            <a:solidFill>
-              <a:srgbClr val="00C853"/>
-            </a:solidFill>
-          </a:ln>
-        </p:spPr>
-        <p:style>
-          <a:lnRef idx="1">
-            <a:schemeClr val="accent1"/>
-          </a:lnRef>
-          <a:fillRef idx="3">
-            <a:schemeClr val="accent1"/>
-          </a:fillRef>
-          <a:effectRef idx="2">
-            <a:schemeClr val="accent1"/>
-          </a:effectRef>
-          <a:fontRef idx="minor">
-            <a:schemeClr val="lt1"/>
-          </a:fontRef>
-        </p:style>
-        <p:txBody>
-          <a:bodyPr rtlCol="0" anchor="ctr" wrap="square" lIns="182880" tIns="182880"/>
-          <a:lstStyle/>
-          <a:p>
-            <a:pPr algn="ctr">
-              <a:defRPr sz="1600" b="1">
-                <a:solidFill>
-                  <a:srgbClr val="00FF66"/>
-                </a:solidFill>
-                <a:latin typeface="Poppins"/>
-              </a:defRPr>
-            </a:pPr>
-            <a:r>
-              <a:t>🌿 Environmental</a:t>
-            </a:r>
-          </a:p>
-          <a:p>
-            <a:pPr>
-              <a:spcBef>
-                <a:spcPts val="800"/>
-              </a:spcBef>
-              <a:defRPr sz="1100">
-                <a:solidFill>
-                  <a:srgbClr val="FFFFFF"/>
-                </a:solidFill>
-                <a:latin typeface="Inter"/>
-              </a:defRPr>
-            </a:pPr>
-            <a:r>
-              <a:t>Reduced carbon footprint, zero waste overflow, water conservation.</a:t>
-            </a:r>
-          </a:p>
-        </p:txBody>
-      </p:sp>
-      <p:sp>
-        <p:nvSpPr>
-          <p:cNvPr id="4" name="Rounded Rectangle 3"/>
-          <p:cNvSpPr/>
-          <p:nvPr/>
-        </p:nvSpPr>
-        <p:spPr>
-          <a:xfrm>
-            <a:off x="4389120" y="1645920"/>
-            <a:ext cx="3383280" cy="2011680"/>
-          </a:xfrm>
-          <a:prstGeom prst="roundRect">
-            <a:avLst/>
-          </a:prstGeom>
-          <a:solidFill>
-            <a:srgbClr val="0E2A1F"/>
-          </a:solidFill>
-          <a:ln w="19050">
-            <a:solidFill>
-              <a:srgbClr val="00C853"/>
-            </a:solidFill>
-          </a:ln>
-        </p:spPr>
-        <p:style>
-          <a:lnRef idx="1">
-            <a:schemeClr val="accent1"/>
-          </a:lnRef>
-          <a:fillRef idx="3">
-            <a:schemeClr val="accent1"/>
-          </a:fillRef>
-          <a:effectRef idx="2">
-            <a:schemeClr val="accent1"/>
-          </a:effectRef>
-          <a:fontRef idx="minor">
-            <a:schemeClr val="lt1"/>
-          </a:fontRef>
-        </p:style>
-        <p:txBody>
-          <a:bodyPr rtlCol="0" anchor="ctr" wrap="square" lIns="182880" tIns="182880"/>
-          <a:lstStyle/>
-          <a:p>
-            <a:pPr algn="ctr">
-              <a:defRPr sz="1600" b="1">
-                <a:solidFill>
-                  <a:srgbClr val="00FF66"/>
-                </a:solidFill>
-                <a:latin typeface="Poppins"/>
-              </a:defRPr>
-            </a:pPr>
-            <a:r>
-              <a:t>💰 Economic</a:t>
-            </a:r>
-          </a:p>
-          <a:p>
-            <a:pPr>
-              <a:spcBef>
-                <a:spcPts val="800"/>
-              </a:spcBef>
-              <a:defRPr sz="1100">
-                <a:solidFill>
-                  <a:srgbClr val="FFFFFF"/>
-                </a:solidFill>
-                <a:latin typeface="Inter"/>
-              </a:defRPr>
-            </a:pPr>
-            <a:r>
-              <a:t>25% lower facilities maintenance costs, lower electricity grid bills.</a:t>
-            </a:r>
-          </a:p>
-        </p:txBody>
-      </p:sp>
-      <p:sp>
-        <p:nvSpPr>
-          <p:cNvPr id="5" name="Rounded Rectangle 4"/>
-          <p:cNvSpPr/>
-          <p:nvPr/>
-        </p:nvSpPr>
-        <p:spPr>
-          <a:xfrm>
-            <a:off x="8046720" y="1645920"/>
-            <a:ext cx="3383280" cy="2011680"/>
-          </a:xfrm>
-          <a:prstGeom prst="roundRect">
-            <a:avLst/>
-          </a:prstGeom>
-          <a:solidFill>
-            <a:srgbClr val="0E2A1F"/>
-          </a:solidFill>
-          <a:ln w="19050">
-            <a:solidFill>
-              <a:srgbClr val="00C853"/>
-            </a:solidFill>
-          </a:ln>
-        </p:spPr>
-        <p:style>
-          <a:lnRef idx="1">
-            <a:schemeClr val="accent1"/>
-          </a:lnRef>
-          <a:fillRef idx="3">
-            <a:schemeClr val="accent1"/>
-          </a:fillRef>
-          <a:effectRef idx="2">
-            <a:schemeClr val="accent1"/>
-          </a:effectRef>
-          <a:fontRef idx="minor">
-            <a:schemeClr val="lt1"/>
-          </a:fontRef>
-        </p:style>
-        <p:txBody>
-          <a:bodyPr rtlCol="0" anchor="ctr" wrap="square" lIns="182880" tIns="182880"/>
-          <a:lstStyle/>
-          <a:p>
-            <a:pPr algn="ctr">
-              <a:defRPr sz="1600" b="1">
-                <a:solidFill>
-                  <a:srgbClr val="00FF66"/>
-                </a:solidFill>
-                <a:latin typeface="Poppins"/>
-              </a:defRPr>
-            </a:pPr>
-            <a:r>
-              <a:t>👥 Social</a:t>
-            </a:r>
-          </a:p>
-          <a:p>
-            <a:pPr>
-              <a:spcBef>
-                <a:spcPts val="800"/>
-              </a:spcBef>
-              <a:defRPr sz="1100">
-                <a:solidFill>
-                  <a:srgbClr val="FFFFFF"/>
-                </a:solidFill>
-                <a:latin typeface="Inter"/>
-              </a:defRPr>
-            </a:pPr>
-            <a:r>
-              <a:t>Active student civic engagement, clean and healthy campus grounds.</a:t>
-            </a:r>
-          </a:p>
-        </p:txBody>
-      </p:sp>
-      <p:sp>
-        <p:nvSpPr>
-          <p:cNvPr id="6" name="Rounded Rectangle 5"/>
-          <p:cNvSpPr/>
-          <p:nvPr/>
-        </p:nvSpPr>
-        <p:spPr>
-          <a:xfrm>
-            <a:off x="731520" y="4023360"/>
-            <a:ext cx="3383280" cy="2011680"/>
-          </a:xfrm>
-          <a:prstGeom prst="roundRect">
-            <a:avLst/>
-          </a:prstGeom>
-          <a:solidFill>
-            <a:srgbClr val="0E2A1F"/>
-          </a:solidFill>
-          <a:ln w="19050">
-            <a:solidFill>
-              <a:srgbClr val="00C853"/>
-            </a:solidFill>
-          </a:ln>
-        </p:spPr>
-        <p:style>
-          <a:lnRef idx="1">
-            <a:schemeClr val="accent1"/>
-          </a:lnRef>
-          <a:fillRef idx="3">
-            <a:schemeClr val="accent1"/>
-          </a:fillRef>
-          <a:effectRef idx="2">
-            <a:schemeClr val="accent1"/>
-          </a:effectRef>
-          <a:fontRef idx="minor">
-            <a:schemeClr val="lt1"/>
-          </a:fontRef>
-        </p:style>
-        <p:txBody>
-          <a:bodyPr rtlCol="0" anchor="ctr" wrap="square" lIns="182880" tIns="182880"/>
-          <a:lstStyle/>
-          <a:p>
-            <a:pPr algn="ctr">
-              <a:defRPr sz="1600" b="1">
-                <a:solidFill>
-                  <a:srgbClr val="00FF66"/>
-                </a:solidFill>
-                <a:latin typeface="Poppins"/>
-              </a:defRPr>
-            </a:pPr>
-            <a:r>
-              <a:t>🎓 Educational</a:t>
-            </a:r>
-          </a:p>
-          <a:p>
-            <a:pPr>
-              <a:spcBef>
-                <a:spcPts val="800"/>
-              </a:spcBef>
-              <a:defRPr sz="1100">
-                <a:solidFill>
-                  <a:srgbClr val="FFFFFF"/>
-                </a:solidFill>
-                <a:latin typeface="Inter"/>
-              </a:defRPr>
-            </a:pPr>
-            <a:r>
-              <a:t>Living research laboratory for engineering students &amp; green skills.</a:t>
-            </a:r>
-          </a:p>
-        </p:txBody>
-      </p:sp>
-      <p:sp>
-        <p:nvSpPr>
-          <p:cNvPr id="7" name="Rounded Rectangle 6"/>
-          <p:cNvSpPr/>
-          <p:nvPr/>
-        </p:nvSpPr>
-        <p:spPr>
-          <a:xfrm>
-            <a:off x="4389120" y="4023360"/>
-            <a:ext cx="3383280" cy="2011680"/>
-          </a:xfrm>
-          <a:prstGeom prst="roundRect">
-            <a:avLst/>
-          </a:prstGeom>
-          <a:solidFill>
-            <a:srgbClr val="0E2A1F"/>
-          </a:solidFill>
-          <a:ln w="19050">
-            <a:solidFill>
-              <a:srgbClr val="00C853"/>
-            </a:solidFill>
-          </a:ln>
-        </p:spPr>
-        <p:style>
-          <a:lnRef idx="1">
-            <a:schemeClr val="accent1"/>
-          </a:lnRef>
-          <a:fillRef idx="3">
-            <a:schemeClr val="accent1"/>
-          </a:fillRef>
-          <a:effectRef idx="2">
-            <a:schemeClr val="accent1"/>
-          </a:effectRef>
-          <a:fontRef idx="minor">
-            <a:schemeClr val="lt1"/>
-          </a:fontRef>
-        </p:style>
-        <p:txBody>
-          <a:bodyPr rtlCol="0" anchor="ctr" wrap="square" lIns="182880" tIns="182880"/>
-          <a:lstStyle/>
-          <a:p>
-            <a:pPr algn="ctr">
-              <a:defRPr sz="1600" b="1">
-                <a:solidFill>
-                  <a:srgbClr val="00FF66"/>
-                </a:solidFill>
-                <a:latin typeface="Poppins"/>
-              </a:defRPr>
-            </a:pPr>
-            <a:r>
-              <a:t>⚙️ Technological</a:t>
-            </a:r>
-          </a:p>
-          <a:p>
-            <a:pPr>
-              <a:spcBef>
-                <a:spcPts val="800"/>
-              </a:spcBef>
-              <a:defRPr sz="1100">
-                <a:solidFill>
-                  <a:srgbClr val="FFFFFF"/>
-                </a:solidFill>
-                <a:latin typeface="Inter"/>
-              </a:defRPr>
-            </a:pPr>
-            <a:r>
-              <a:t>Scalable IoT edge architecture, Google Gemini AI integration.</a:t>
-            </a:r>
-          </a:p>
-        </p:txBody>
-      </p:sp>
-      <p:sp>
-        <p:nvSpPr>
-          <p:cNvPr id="8" name="Rounded Rectangle 7"/>
-          <p:cNvSpPr/>
-          <p:nvPr/>
-        </p:nvSpPr>
-        <p:spPr>
-          <a:xfrm>
-            <a:off x="8046720" y="4023360"/>
-            <a:ext cx="3383280" cy="2011680"/>
-          </a:xfrm>
-          <a:prstGeom prst="roundRect">
-            <a:avLst/>
-          </a:prstGeom>
-          <a:solidFill>
-            <a:srgbClr val="0E2A1F"/>
-          </a:solidFill>
-          <a:ln w="19050">
-            <a:solidFill>
-              <a:srgbClr val="00C853"/>
-            </a:solidFill>
-          </a:ln>
-        </p:spPr>
-        <p:style>
-          <a:lnRef idx="1">
-            <a:schemeClr val="accent1"/>
-          </a:lnRef>
-          <a:fillRef idx="3">
-            <a:schemeClr val="accent1"/>
-          </a:fillRef>
-          <a:effectRef idx="2">
-            <a:schemeClr val="accent1"/>
-          </a:effectRef>
-          <a:fontRef idx="minor">
-            <a:schemeClr val="lt1"/>
-          </a:fontRef>
-        </p:style>
-        <p:txBody>
-          <a:bodyPr rtlCol="0" anchor="ctr" wrap="square" lIns="182880" tIns="182880"/>
-          <a:lstStyle/>
-          <a:p>
-            <a:pPr algn="ctr">
-              <a:defRPr sz="1600" b="1">
-                <a:solidFill>
-                  <a:srgbClr val="00FF66"/>
-                </a:solidFill>
-                <a:latin typeface="Poppins"/>
-              </a:defRPr>
-            </a:pPr>
-            <a:r>
-              <a:t>🏛️ Government</a:t>
-            </a:r>
-          </a:p>
-          <a:p>
-            <a:pPr>
-              <a:spcBef>
-                <a:spcPts val="800"/>
-              </a:spcBef>
-              <a:defRPr sz="1100">
-                <a:solidFill>
-                  <a:srgbClr val="FFFFFF"/>
-                </a:solidFill>
-                <a:latin typeface="Inter"/>
-              </a:defRPr>
-            </a:pPr>
-            <a:r>
-              <a:t>Supports Bihar DST green campus targets &amp; Microsoft ESG goals.</a:t>
-            </a:r>
-          </a:p>
-        </p:txBody>
-      </p:sp>
-    </p:spTree>
-  </p:cSld>
-  <p:clrMapOvr>
-    <a:masterClrMapping/>
-  </p:clrMapOvr>
-</p:sld>
-</file>
-
-<file path=ppt/slides/slide12.xml><?xml version="1.0" encoding="utf-8"?>
-<p:sld xmlns:a="http://schemas.openxmlformats.org/drawingml/2006/main" xmlns:p="http://schemas.openxmlformats.org/presentationml/2006/main" xmlns:r="http://schemas.openxmlformats.org/officeDocument/2006/relationships">
-  <p:cSld>
-    <p:bg>
-      <p:bgPr>
-        <a:solidFill>
-          <a:srgbClr val="071A12"/>
-        </a:solidFill>
-        <a:effectLst/>
-      </p:bgPr>
-    </p:bg>
-    <p:spTree>
-      <p:nvGrpSpPr>
-        <p:cNvPr id="1" name=""/>
-        <p:cNvGrpSpPr/>
-        <p:nvPr/>
-      </p:nvGrpSpPr>
-      <p:grpSpPr/>
-      <p:sp>
-        <p:nvSpPr>
-          <p:cNvPr id="2" name="Rounded Rectangle 1"/>
-          <p:cNvSpPr/>
-          <p:nvPr/>
-        </p:nvSpPr>
-        <p:spPr>
-          <a:xfrm>
-            <a:off x="731520" y="731520"/>
-            <a:ext cx="6858000" cy="5394960"/>
-          </a:xfrm>
-          <a:prstGeom prst="roundRect">
-            <a:avLst/>
-          </a:prstGeom>
-          <a:solidFill>
-            <a:srgbClr val="0E2A1F"/>
-          </a:solidFill>
-          <a:ln w="19050">
-            <a:solidFill>
-              <a:srgbClr val="00FF66"/>
-            </a:solidFill>
-          </a:ln>
-        </p:spPr>
-        <p:style>
-          <a:lnRef idx="1">
-            <a:schemeClr val="accent1"/>
-          </a:lnRef>
-          <a:fillRef idx="3">
-            <a:schemeClr val="accent1"/>
-          </a:fillRef>
-          <a:effectRef idx="2">
-            <a:schemeClr val="accent1"/>
-          </a:effectRef>
-          <a:fontRef idx="minor">
-            <a:schemeClr val="lt1"/>
-          </a:fontRef>
-        </p:style>
-        <p:txBody>
-          <a:bodyPr rtlCol="0" anchor="ctr" wrap="square" lIns="274320" tIns="274320"/>
-          <a:lstStyle/>
-          <a:p>
-            <a:pPr algn="ctr">
-              <a:defRPr sz="3600" b="1">
-                <a:solidFill>
-                  <a:srgbClr val="00FF66"/>
-                </a:solidFill>
-                <a:latin typeface="Poppins"/>
-              </a:defRPr>
-            </a:pPr>
-            <a:r>
-              <a:t>THANK YOU!</a:t>
-            </a:r>
-          </a:p>
-          <a:p>
-            <a:pPr>
-              <a:spcBef>
-                <a:spcPts val="600"/>
-              </a:spcBef>
-              <a:defRPr sz="1600" b="1">
-                <a:solidFill>
-                  <a:srgbClr val="FFFFFF"/>
-                </a:solidFill>
-                <a:latin typeface="Poppins"/>
-              </a:defRPr>
-            </a:pPr>
-            <a:r>
-              <a:t>Building Smarter, Greener &amp; Sustainable Campuses with AI + IoT</a:t>
-            </a:r>
-          </a:p>
-          <a:p>
-            <a:pPr>
-              <a:spcBef>
-                <a:spcPts val="1200"/>
-              </a:spcBef>
-              <a:defRPr sz="1100">
-                <a:solidFill>
-                  <a:srgbClr val="B2DFDB"/>
-                </a:solidFill>
-                <a:latin typeface="Inter"/>
-              </a:defRPr>
-            </a:pPr>
-            <a:r>
-              <a:t>🌐 Live Website: https://green-verse-ai-smart-campus-sustain.vercel.app</a:t>
-            </a:r>
-            <a:br/>
-            <a:r>
-              <a:t>💻 GitHub: https://github.com/yashkumar5224/GreenVerse-AI-Smart-Campus-Sustainability-Maintenance-Platform.git</a:t>
-            </a:r>
-            <a:br/>
-            <a:r>
-              <a:t>🏛️ Institution: Shri Phanishwar Nath Renu Engineering College (SPNREC), Araria</a:t>
-            </a:r>
-            <a:br/>
-            <a:r>
-              <a:t>🏅 Internship: 1M1B Applied AI Initiative (Microsoft Supported)</a:t>
-            </a:r>
-            <a:br/>
-            <a:r>
-              <a:t>👥 Team: Sustainability Green Warriors (Yash Kumar, Neha, Suraj, Utkarsh)</a:t>
-            </a:r>
-          </a:p>
-        </p:txBody>
-      </p:sp>
-      <p:sp>
-        <p:nvSpPr>
-          <p:cNvPr id="3" name="Rounded Rectangle 2"/>
-          <p:cNvSpPr/>
-          <p:nvPr/>
-        </p:nvSpPr>
-        <p:spPr>
-          <a:xfrm>
-            <a:off x="7863840" y="731520"/>
-            <a:ext cx="3566160" cy="5394960"/>
-          </a:xfrm>
-          <a:prstGeom prst="roundRect">
-            <a:avLst/>
-          </a:prstGeom>
-          <a:solidFill>
-            <a:srgbClr val="0E2A1F"/>
-          </a:solidFill>
-          <a:ln w="19050">
-            <a:solidFill>
-              <a:srgbClr val="00E5FF"/>
-            </a:solidFill>
-          </a:ln>
-        </p:spPr>
-        <p:style>
-          <a:lnRef idx="1">
-            <a:schemeClr val="accent1"/>
-          </a:lnRef>
-          <a:fillRef idx="3">
-            <a:schemeClr val="accent1"/>
-          </a:fillRef>
-          <a:effectRef idx="2">
-            <a:schemeClr val="accent1"/>
-          </a:effectRef>
-          <a:fontRef idx="minor">
-            <a:schemeClr val="lt1"/>
-          </a:fontRef>
-        </p:style>
-        <p:txBody>
-          <a:bodyPr rtlCol="0" anchor="ctr"/>
-          <a:lstStyle/>
-          <a:p>
-            <a:pPr algn="ctr"/>
-          </a:p>
-        </p:txBody>
-      </p:sp>
-      <p:pic>
-        <p:nvPicPr>
-          <p:cNvPr id="4" name="Picture 3" descr="3d_smart_campus.jpg"/>
-          <p:cNvPicPr>
-            <a:picLocks noChangeAspect="1"/>
-          </p:cNvPicPr>
-          <p:nvPr/>
-        </p:nvPicPr>
-        <p:blipFill>
-          <a:blip r:embed="rId2"/>
-          <a:stretch>
-            <a:fillRect/>
-          </a:stretch>
-        </p:blipFill>
-        <p:spPr>
-          <a:xfrm>
-            <a:off x="7955279" y="822960"/>
-            <a:ext cx="3383280" cy="5212080"/>
           </a:xfrm>
           <a:prstGeom prst="rect">
             <a:avLst/>
@@ -4598,8 +3459,8 @@
         </p:nvSpPr>
         <p:spPr>
           <a:xfrm>
-            <a:off x="731520" y="365760"/>
-            <a:ext cx="10728655" cy="914400"/>
+            <a:off x="731520" y="274320"/>
+            <a:ext cx="10728655" cy="822960"/>
           </a:xfrm>
           <a:prstGeom prst="rect">
             <a:avLst/>
@@ -4613,7 +3474,7 @@
           <a:lstStyle/>
           <a:p>
             <a:pPr>
-              <a:defRPr sz="2800" b="1">
+              <a:defRPr sz="2600" b="1">
                 <a:solidFill>
                   <a:srgbClr val="FFFFFF"/>
                 </a:solidFill>
@@ -4621,15 +3482,15 @@
               </a:defRPr>
             </a:pPr>
             <a:r>
-              <a:t>PROBLEM STATEMENT</a:t>
+              <a:t>Slide 2  |  Problem Statement &amp; Solution Overview</a:t>
             </a:r>
           </a:p>
           <a:p>
             <a:pPr>
               <a:spcBef>
-                <a:spcPts val="400"/>
+                <a:spcPts val="300"/>
               </a:spcBef>
-              <a:defRPr sz="1300">
+              <a:defRPr sz="1200">
                 <a:solidFill>
                   <a:srgbClr val="00E5FF"/>
                 </a:solidFill>
@@ -4637,7 +3498,7 @@
               </a:defRPr>
             </a:pPr>
             <a:r>
-              <a:t>Challenges Facing Modern Educational Campuses Today</a:t>
+              <a:t>Solving Campus Waste, Energy, Water, and Carbon Challenges</a:t>
             </a:r>
           </a:p>
         </p:txBody>
@@ -4680,11 +3541,11 @@
           </a:fontRef>
         </p:style>
         <p:txBody>
-          <a:bodyPr rtlCol="0" anchor="ctr" wrap="square" lIns="182880" rIns="182880" tIns="182880"/>
+          <a:bodyPr rtlCol="0" anchor="ctr" wrap="square" lIns="182880" tIns="182880"/>
           <a:lstStyle/>
           <a:p>
             <a:pPr algn="ctr">
-              <a:defRPr sz="1600" b="1">
+              <a:defRPr sz="1500" b="1">
                 <a:solidFill>
                   <a:srgbClr val="00FF66"/>
                 </a:solidFill>
@@ -4698,9 +3559,9 @@
           <a:p>
             <a:pPr>
               <a:spcBef>
-                <a:spcPts val="1400"/>
+                <a:spcPts val="1200"/>
               </a:spcBef>
-              <a:defRPr sz="1200">
+              <a:defRPr sz="1100">
                 <a:solidFill>
                   <a:srgbClr val="B2DFDB"/>
                 </a:solidFill>
@@ -4708,15 +3569,15 @@
               </a:defRPr>
             </a:pPr>
             <a:r>
-              <a:t>Manual bin inspections lead to overflow, littering, and unhygienic campus environments.</a:t>
+              <a:t>Manual bin inspections lead to overflow, littering, and unhygienic campus grounds.</a:t>
             </a:r>
           </a:p>
           <a:p>
             <a:pPr>
               <a:spcBef>
-                <a:spcPts val="2400"/>
+                <a:spcPts val="2000"/>
               </a:spcBef>
-              <a:defRPr sz="1800" b="1">
+              <a:defRPr sz="1600" b="1">
                 <a:solidFill>
                   <a:srgbClr val="00E5FF"/>
                 </a:solidFill>
@@ -4724,7 +3585,7 @@
               </a:defRPr>
             </a:pPr>
             <a:r>
-              <a:t>85% Overflow Rate</a:t>
+              <a:t>85% Overflow</a:t>
             </a:r>
           </a:p>
         </p:txBody>
@@ -4767,11 +3628,11 @@
           </a:fontRef>
         </p:style>
         <p:txBody>
-          <a:bodyPr rtlCol="0" anchor="ctr" wrap="square" lIns="182880" rIns="182880" tIns="182880"/>
+          <a:bodyPr rtlCol="0" anchor="ctr" wrap="square" lIns="182880" tIns="182880"/>
           <a:lstStyle/>
           <a:p>
             <a:pPr algn="ctr">
-              <a:defRPr sz="1600" b="1">
+              <a:defRPr sz="1500" b="1">
                 <a:solidFill>
                   <a:srgbClr val="00FF66"/>
                 </a:solidFill>
@@ -4785,9 +3646,9 @@
           <a:p>
             <a:pPr>
               <a:spcBef>
-                <a:spcPts val="1400"/>
+                <a:spcPts val="1200"/>
               </a:spcBef>
-              <a:defRPr sz="1200">
+              <a:defRPr sz="1100">
                 <a:solidFill>
                   <a:srgbClr val="B2DFDB"/>
                 </a:solidFill>
@@ -4795,15 +3656,15 @@
               </a:defRPr>
             </a:pPr>
             <a:r>
-              <a:t>Unmonitored HVAC and lighting lead to massive grid power waste and excess operational costs.</a:t>
+              <a:t>Unmonitored HVAC and lighting lead to massive grid power waste and operational costs.</a:t>
             </a:r>
           </a:p>
           <a:p>
             <a:pPr>
               <a:spcBef>
-                <a:spcPts val="2400"/>
+                <a:spcPts val="2000"/>
               </a:spcBef>
-              <a:defRPr sz="1800" b="1">
+              <a:defRPr sz="1600" b="1">
                 <a:solidFill>
                   <a:srgbClr val="00E5FF"/>
                 </a:solidFill>
@@ -4854,11 +3715,11 @@
           </a:fontRef>
         </p:style>
         <p:txBody>
-          <a:bodyPr rtlCol="0" anchor="ctr" wrap="square" lIns="182880" rIns="182880" tIns="182880"/>
+          <a:bodyPr rtlCol="0" anchor="ctr" wrap="square" lIns="182880" tIns="182880"/>
           <a:lstStyle/>
           <a:p>
             <a:pPr algn="ctr">
-              <a:defRPr sz="1600" b="1">
+              <a:defRPr sz="1500" b="1">
                 <a:solidFill>
                   <a:srgbClr val="00FF66"/>
                 </a:solidFill>
@@ -4872,9 +3733,9 @@
           <a:p>
             <a:pPr>
               <a:spcBef>
-                <a:spcPts val="1400"/>
+                <a:spcPts val="1200"/>
               </a:spcBef>
-              <a:defRPr sz="1200">
+              <a:defRPr sz="1100">
                 <a:solidFill>
                   <a:srgbClr val="B2DFDB"/>
                 </a:solidFill>
@@ -4888,9 +3749,9 @@
           <a:p>
             <a:pPr>
               <a:spcBef>
-                <a:spcPts val="2400"/>
+                <a:spcPts val="2000"/>
               </a:spcBef>
-              <a:defRPr sz="1800" b="1">
+              <a:defRPr sz="1600" b="1">
                 <a:solidFill>
                   <a:srgbClr val="00E5FF"/>
                 </a:solidFill>
@@ -4941,11 +3802,11 @@
           </a:fontRef>
         </p:style>
         <p:txBody>
-          <a:bodyPr rtlCol="0" anchor="ctr" wrap="square" lIns="182880" rIns="182880" tIns="182880"/>
+          <a:bodyPr rtlCol="0" anchor="ctr" wrap="square" lIns="182880" tIns="182880"/>
           <a:lstStyle/>
           <a:p>
             <a:pPr algn="ctr">
-              <a:defRPr sz="1600" b="1">
+              <a:defRPr sz="1500" b="1">
                 <a:solidFill>
                   <a:srgbClr val="00FF66"/>
                 </a:solidFill>
@@ -4953,15 +3814,15 @@
               </a:defRPr>
             </a:pPr>
             <a:r>
-              <a:t>🌿 Carbon Emissions</a:t>
+              <a:t>🌿 Carbon Footprint</a:t>
             </a:r>
           </a:p>
           <a:p>
             <a:pPr>
               <a:spcBef>
-                <a:spcPts val="1400"/>
+                <a:spcPts val="1200"/>
               </a:spcBef>
-              <a:defRPr sz="1200">
+              <a:defRPr sz="1100">
                 <a:solidFill>
                   <a:srgbClr val="B2DFDB"/>
                 </a:solidFill>
@@ -4969,15 +3830,15 @@
               </a:defRPr>
             </a:pPr>
             <a:r>
-              <a:t>High reliance on non-renewable grid energy increases campus carbon footprints.</a:t>
+              <a:t>High reliance on non-renewable grid power increases campus carbon emissions.</a:t>
             </a:r>
           </a:p>
           <a:p>
             <a:pPr>
               <a:spcBef>
-                <a:spcPts val="2400"/>
+                <a:spcPts val="2000"/>
               </a:spcBef>
-              <a:defRPr sz="1800" b="1">
+              <a:defRPr sz="1600" b="1">
                 <a:solidFill>
                   <a:srgbClr val="00E5FF"/>
                 </a:solidFill>
@@ -5024,8 +3885,8 @@
         </p:nvSpPr>
         <p:spPr>
           <a:xfrm>
-            <a:off x="731520" y="365760"/>
-            <a:ext cx="10728655" cy="914400"/>
+            <a:off x="731520" y="274320"/>
+            <a:ext cx="10728655" cy="822960"/>
           </a:xfrm>
           <a:prstGeom prst="rect">
             <a:avLst/>
@@ -5039,7 +3900,7 @@
           <a:lstStyle/>
           <a:p>
             <a:pPr>
-              <a:defRPr sz="2800" b="1">
+              <a:defRPr sz="2600" b="1">
                 <a:solidFill>
                   <a:srgbClr val="FFFFFF"/>
                 </a:solidFill>
@@ -5047,15 +3908,15 @@
               </a:defRPr>
             </a:pPr>
             <a:r>
-              <a:t>OUR SOLUTION: GREENVERSE PLATFORM</a:t>
+              <a:t>Slide 3  |  System Architecture &amp; Data Pipeline</a:t>
             </a:r>
           </a:p>
           <a:p>
             <a:pPr>
               <a:spcBef>
-                <a:spcPts val="400"/>
+                <a:spcPts val="300"/>
               </a:spcBef>
-              <a:defRPr sz="1300">
+              <a:defRPr sz="1200">
                 <a:solidFill>
                   <a:srgbClr val="00E5FF"/>
                 </a:solidFill>
@@ -5063,7 +3924,7 @@
               </a:defRPr>
             </a:pPr>
             <a:r>
-              <a:t>Central AI-IoT Core Connecting Campus Infrastructure</a:t>
+              <a:t>End-to-End IoT Sensors, Supabase Cloud, Gemini AI &amp; Mobile App</a:t>
             </a:r>
           </a:p>
         </p:txBody>
@@ -5076,8 +3937,8 @@
         </p:nvSpPr>
         <p:spPr>
           <a:xfrm>
-            <a:off x="4389120" y="1645920"/>
-            <a:ext cx="3383280" cy="4572000"/>
+            <a:off x="731520" y="1645920"/>
+            <a:ext cx="3291840" cy="4389120"/>
           </a:xfrm>
           <a:prstGeom prst="roundRect">
             <a:avLst/>
@@ -5087,7 +3948,7 @@
           </a:solidFill>
           <a:ln w="19050">
             <a:solidFill>
-              <a:srgbClr val="00FF66"/>
+              <a:srgbClr val="00E5FF"/>
             </a:solidFill>
           </a:ln>
         </p:spPr>
@@ -5106,54 +3967,16 @@
           </a:fontRef>
         </p:style>
         <p:txBody>
-          <a:bodyPr rtlCol="0" anchor="ctr" wrap="square" lIns="182880" rIns="182880" tIns="2286000"/>
-          <a:lstStyle/>
-          <a:p>
-            <a:pPr algn="ctr">
-              <a:defRPr sz="1500" b="1">
-                <a:solidFill>
-                  <a:srgbClr val="00FF66"/>
-                </a:solidFill>
-                <a:latin typeface="Poppins"/>
-              </a:defRPr>
-            </a:pPr>
-            <a:r>
-              <a:t>🤖 GREENVERSE AI ENGINE</a:t>
-            </a:r>
-          </a:p>
-          <a:p>
-            <a:pPr>
-              <a:spcBef>
-                <a:spcPts val="600"/>
-              </a:spcBef>
-              <a:defRPr sz="1100">
-                <a:solidFill>
-                  <a:srgbClr val="FFFFFF"/>
-                </a:solidFill>
-                <a:latin typeface="Inter"/>
-              </a:defRPr>
-            </a:pPr>
-            <a:r>
-              <a:t>• Google Gemini AI Analysis</a:t>
-            </a:r>
-            <a:br/>
-            <a:r>
-              <a:t>• Realtime Sensor Streams</a:t>
-            </a:r>
-            <a:br/>
-            <a:r>
-              <a:t>• Auto Defect Work Orders</a:t>
-            </a:r>
-            <a:br/>
-            <a:r>
-              <a:t>• Carbon Offset Audit</a:t>
-            </a:r>
+          <a:bodyPr rtlCol="0" anchor="ctr"/>
+          <a:lstStyle/>
+          <a:p>
+            <a:pPr algn="ctr"/>
           </a:p>
         </p:txBody>
       </p:sp>
       <p:pic>
         <p:nvPicPr>
-          <p:cNvPr id="4" name="Picture 3" descr="3d_ai_brain.jpg"/>
+          <p:cNvPr id="4" name="Picture 3" descr="3d_iot_sensors.jpg"/>
           <p:cNvPicPr>
             <a:picLocks noChangeAspect="1"/>
           </p:cNvPicPr>
@@ -5167,8 +3990,8 @@
         </p:blipFill>
         <p:spPr>
           <a:xfrm>
-            <a:off x="4480560" y="1737360"/>
-            <a:ext cx="3200400" cy="2011680"/>
+            <a:off x="822960" y="1737360"/>
+            <a:ext cx="3108960" cy="4206240"/>
           </a:xfrm>
           <a:prstGeom prst="rect">
             <a:avLst/>
@@ -5183,8 +4006,8 @@
         </p:nvSpPr>
         <p:spPr>
           <a:xfrm>
-            <a:off x="731520" y="1645920"/>
-            <a:ext cx="3200400" cy="2194560"/>
+            <a:off x="4297680" y="1645920"/>
+            <a:ext cx="2194560" cy="2011680"/>
           </a:xfrm>
           <a:prstGeom prst="roundRect">
             <a:avLst/>
@@ -5213,19 +4036,19 @@
           </a:fontRef>
         </p:style>
         <p:txBody>
-          <a:bodyPr rtlCol="0" anchor="ctr" wrap="square" lIns="182880" tIns="182880"/>
+          <a:bodyPr rtlCol="0" anchor="ctr" wrap="square" lIns="137160" tIns="137160"/>
           <a:lstStyle/>
           <a:p>
             <a:pPr algn="ctr">
-              <a:defRPr sz="1600" b="1">
-                <a:solidFill>
-                  <a:srgbClr val="00E5FF"/>
+              <a:defRPr sz="1400" b="1">
+                <a:solidFill>
+                  <a:srgbClr val="00FF66"/>
                 </a:solidFill>
                 <a:latin typeface="Poppins"/>
               </a:defRPr>
             </a:pPr>
             <a:r>
-              <a:t>🗑️ Smart Bins</a:t>
+              <a:t>1. IoT Sensors</a:t>
             </a:r>
           </a:p>
           <a:p>
@@ -5235,16 +4058,13 @@
               </a:spcBef>
               <a:defRPr sz="1100">
                 <a:solidFill>
-                  <a:srgbClr val="B2DFDB"/>
-                </a:solidFill>
-              </a:defRPr>
-            </a:pPr>
-            <a:r>
-              <a:t>Connected via ESP32 WiFi Mesh</a:t>
-            </a:r>
-            <a:br/>
-            <a:r>
-              <a:t>Streaming live telemetry data 24/7</a:t>
+                  <a:srgbClr val="FFFFFF"/>
+                </a:solidFill>
+                <a:latin typeface="Inter"/>
+              </a:defRPr>
+            </a:pPr>
+            <a:r>
+              <a:t>Smart Bins, Water Pressure, Solar Meter</a:t>
             </a:r>
           </a:p>
         </p:txBody>
@@ -5257,8 +4077,8 @@
         </p:nvSpPr>
         <p:spPr>
           <a:xfrm>
-            <a:off x="731520" y="4023360"/>
-            <a:ext cx="3200400" cy="2194560"/>
+            <a:off x="6675120" y="1645920"/>
+            <a:ext cx="2194560" cy="2011680"/>
           </a:xfrm>
           <a:prstGeom prst="roundRect">
             <a:avLst/>
@@ -5287,19 +4107,19 @@
           </a:fontRef>
         </p:style>
         <p:txBody>
-          <a:bodyPr rtlCol="0" anchor="ctr" wrap="square" lIns="182880" tIns="182880"/>
+          <a:bodyPr rtlCol="0" anchor="ctr" wrap="square" lIns="137160" tIns="137160"/>
           <a:lstStyle/>
           <a:p>
             <a:pPr algn="ctr">
-              <a:defRPr sz="1600" b="1">
-                <a:solidFill>
-                  <a:srgbClr val="00E5FF"/>
+              <a:defRPr sz="1400" b="1">
+                <a:solidFill>
+                  <a:srgbClr val="00FF66"/>
                 </a:solidFill>
                 <a:latin typeface="Poppins"/>
               </a:defRPr>
             </a:pPr>
             <a:r>
-              <a:t>💧 Water Tanks</a:t>
+              <a:t>2. ESP32 Edge</a:t>
             </a:r>
           </a:p>
           <a:p>
@@ -5309,16 +4129,13 @@
               </a:spcBef>
               <a:defRPr sz="1100">
                 <a:solidFill>
-                  <a:srgbClr val="B2DFDB"/>
-                </a:solidFill>
-              </a:defRPr>
-            </a:pPr>
-            <a:r>
-              <a:t>Connected via ESP32 WiFi Mesh</a:t>
-            </a:r>
-            <a:br/>
-            <a:r>
-              <a:t>Streaming live telemetry data 24/7</a:t>
+                  <a:srgbClr val="FFFFFF"/>
+                </a:solidFill>
+                <a:latin typeface="Inter"/>
+              </a:defRPr>
+            </a:pPr>
+            <a:r>
+              <a:t>Microcontroller Data Processing</a:t>
             </a:r>
           </a:p>
         </p:txBody>
@@ -5331,8 +4148,8 @@
         </p:nvSpPr>
         <p:spPr>
           <a:xfrm>
-            <a:off x="8046720" y="1645920"/>
-            <a:ext cx="3200400" cy="2194560"/>
+            <a:off x="9052560" y="1645920"/>
+            <a:ext cx="2194560" cy="2011680"/>
           </a:xfrm>
           <a:prstGeom prst="roundRect">
             <a:avLst/>
@@ -5361,19 +4178,19 @@
           </a:fontRef>
         </p:style>
         <p:txBody>
-          <a:bodyPr rtlCol="0" anchor="ctr" wrap="square" lIns="182880" tIns="182880"/>
+          <a:bodyPr rtlCol="0" anchor="ctr" wrap="square" lIns="137160" tIns="137160"/>
           <a:lstStyle/>
           <a:p>
             <a:pPr algn="ctr">
-              <a:defRPr sz="1600" b="1">
-                <a:solidFill>
-                  <a:srgbClr val="00E5FF"/>
+              <a:defRPr sz="1400" b="1">
+                <a:solidFill>
+                  <a:srgbClr val="00FF66"/>
                 </a:solidFill>
                 <a:latin typeface="Poppins"/>
               </a:defRPr>
             </a:pPr>
             <a:r>
-              <a:t>⚡ 250kW Solar</a:t>
+              <a:t>3. WiFi Gateway</a:t>
             </a:r>
           </a:p>
           <a:p>
@@ -5383,16 +4200,13 @@
               </a:spcBef>
               <a:defRPr sz="1100">
                 <a:solidFill>
-                  <a:srgbClr val="B2DFDB"/>
-                </a:solidFill>
-              </a:defRPr>
-            </a:pPr>
-            <a:r>
-              <a:t>Connected via ESP32 WiFi Mesh</a:t>
-            </a:r>
-            <a:br/>
-            <a:r>
-              <a:t>Streaming live telemetry data 24/7</a:t>
+                  <a:srgbClr val="FFFFFF"/>
+                </a:solidFill>
+                <a:latin typeface="Inter"/>
+              </a:defRPr>
+            </a:pPr>
+            <a:r>
+              <a:t>Encrypted Telemetry Transmission</a:t>
             </a:r>
           </a:p>
         </p:txBody>
@@ -5405,8 +4219,8 @@
         </p:nvSpPr>
         <p:spPr>
           <a:xfrm>
-            <a:off x="8046720" y="4023360"/>
-            <a:ext cx="3200400" cy="2194560"/>
+            <a:off x="4297680" y="3931920"/>
+            <a:ext cx="2194560" cy="2011680"/>
           </a:xfrm>
           <a:prstGeom prst="roundRect">
             <a:avLst/>
@@ -5435,19 +4249,19 @@
           </a:fontRef>
         </p:style>
         <p:txBody>
-          <a:bodyPr rtlCol="0" anchor="ctr" wrap="square" lIns="182880" tIns="182880"/>
+          <a:bodyPr rtlCol="0" anchor="ctr" wrap="square" lIns="137160" tIns="137160"/>
           <a:lstStyle/>
           <a:p>
             <a:pPr algn="ctr">
-              <a:defRPr sz="1600" b="1">
-                <a:solidFill>
-                  <a:srgbClr val="00E5FF"/>
+              <a:defRPr sz="1400" b="1">
+                <a:solidFill>
+                  <a:srgbClr val="00FF66"/>
                 </a:solidFill>
                 <a:latin typeface="Poppins"/>
               </a:defRPr>
             </a:pPr>
             <a:r>
-              <a:t>📍 GIS Campus Map</a:t>
+              <a:t>4. Firebase/Supabase</a:t>
             </a:r>
           </a:p>
           <a:p>
@@ -5457,16 +4271,155 @@
               </a:spcBef>
               <a:defRPr sz="1100">
                 <a:solidFill>
-                  <a:srgbClr val="B2DFDB"/>
-                </a:solidFill>
-              </a:defRPr>
-            </a:pPr>
-            <a:r>
-              <a:t>Connected via ESP32 WiFi Mesh</a:t>
-            </a:r>
-            <a:br/>
-            <a:r>
-              <a:t>Streaming live telemetry data 24/7</a:t>
+                  <a:srgbClr val="FFFFFF"/>
+                </a:solidFill>
+                <a:latin typeface="Inter"/>
+              </a:defRPr>
+            </a:pPr>
+            <a:r>
+              <a:t>Realtime Database &amp; Webhooks</a:t>
+            </a:r>
+          </a:p>
+        </p:txBody>
+      </p:sp>
+      <p:sp>
+        <p:nvSpPr>
+          <p:cNvPr id="9" name="Rounded Rectangle 8"/>
+          <p:cNvSpPr/>
+          <p:nvPr/>
+        </p:nvSpPr>
+        <p:spPr>
+          <a:xfrm>
+            <a:off x="6675120" y="3931920"/>
+            <a:ext cx="2194560" cy="2011680"/>
+          </a:xfrm>
+          <a:prstGeom prst="roundRect">
+            <a:avLst/>
+          </a:prstGeom>
+          <a:solidFill>
+            <a:srgbClr val="0E2A1F"/>
+          </a:solidFill>
+          <a:ln w="19050">
+            <a:solidFill>
+              <a:srgbClr val="00C853"/>
+            </a:solidFill>
+          </a:ln>
+        </p:spPr>
+        <p:style>
+          <a:lnRef idx="1">
+            <a:schemeClr val="accent1"/>
+          </a:lnRef>
+          <a:fillRef idx="3">
+            <a:schemeClr val="accent1"/>
+          </a:fillRef>
+          <a:effectRef idx="2">
+            <a:schemeClr val="accent1"/>
+          </a:effectRef>
+          <a:fontRef idx="minor">
+            <a:schemeClr val="lt1"/>
+          </a:fontRef>
+        </p:style>
+        <p:txBody>
+          <a:bodyPr rtlCol="0" anchor="ctr" wrap="square" lIns="137160" tIns="137160"/>
+          <a:lstStyle/>
+          <a:p>
+            <a:pPr algn="ctr">
+              <a:defRPr sz="1400" b="1">
+                <a:solidFill>
+                  <a:srgbClr val="00FF66"/>
+                </a:solidFill>
+                <a:latin typeface="Poppins"/>
+              </a:defRPr>
+            </a:pPr>
+            <a:r>
+              <a:t>5. Gemini AI</a:t>
+            </a:r>
+          </a:p>
+          <a:p>
+            <a:pPr>
+              <a:spcBef>
+                <a:spcPts val="800"/>
+              </a:spcBef>
+              <a:defRPr sz="1100">
+                <a:solidFill>
+                  <a:srgbClr val="FFFFFF"/>
+                </a:solidFill>
+                <a:latin typeface="Inter"/>
+              </a:defRPr>
+            </a:pPr>
+            <a:r>
+              <a:t>Defect Scanning &amp; Predictive Engine</a:t>
+            </a:r>
+          </a:p>
+        </p:txBody>
+      </p:sp>
+      <p:sp>
+        <p:nvSpPr>
+          <p:cNvPr id="10" name="Rounded Rectangle 9"/>
+          <p:cNvSpPr/>
+          <p:nvPr/>
+        </p:nvSpPr>
+        <p:spPr>
+          <a:xfrm>
+            <a:off x="9052560" y="3931920"/>
+            <a:ext cx="2194560" cy="2011680"/>
+          </a:xfrm>
+          <a:prstGeom prst="roundRect">
+            <a:avLst/>
+          </a:prstGeom>
+          <a:solidFill>
+            <a:srgbClr val="0E2A1F"/>
+          </a:solidFill>
+          <a:ln w="19050">
+            <a:solidFill>
+              <a:srgbClr val="00C853"/>
+            </a:solidFill>
+          </a:ln>
+        </p:spPr>
+        <p:style>
+          <a:lnRef idx="1">
+            <a:schemeClr val="accent1"/>
+          </a:lnRef>
+          <a:fillRef idx="3">
+            <a:schemeClr val="accent1"/>
+          </a:fillRef>
+          <a:effectRef idx="2">
+            <a:schemeClr val="accent1"/>
+          </a:effectRef>
+          <a:fontRef idx="minor">
+            <a:schemeClr val="lt1"/>
+          </a:fontRef>
+        </p:style>
+        <p:txBody>
+          <a:bodyPr rtlCol="0" anchor="ctr" wrap="square" lIns="137160" tIns="137160"/>
+          <a:lstStyle/>
+          <a:p>
+            <a:pPr algn="ctr">
+              <a:defRPr sz="1400" b="1">
+                <a:solidFill>
+                  <a:srgbClr val="00FF66"/>
+                </a:solidFill>
+                <a:latin typeface="Poppins"/>
+              </a:defRPr>
+            </a:pPr>
+            <a:r>
+              <a:t>6. Control Center</a:t>
+            </a:r>
+          </a:p>
+          <a:p>
+            <a:pPr>
+              <a:spcBef>
+                <a:spcPts val="800"/>
+              </a:spcBef>
+              <a:defRPr sz="1100">
+                <a:solidFill>
+                  <a:srgbClr val="FFFFFF"/>
+                </a:solidFill>
+                <a:latin typeface="Inter"/>
+              </a:defRPr>
+            </a:pPr>
+            <a:r>
+              <a:t>Admin &amp; Staff Dispatch Dashboard</a:t>
             </a:r>
           </a:p>
         </p:txBody>
@@ -5505,8 +4458,8 @@
         </p:nvSpPr>
         <p:spPr>
           <a:xfrm>
-            <a:off x="731520" y="365760"/>
-            <a:ext cx="10728655" cy="914400"/>
+            <a:off x="731520" y="274320"/>
+            <a:ext cx="10728655" cy="822960"/>
           </a:xfrm>
           <a:prstGeom prst="rect">
             <a:avLst/>
@@ -5520,7 +4473,7 @@
           <a:lstStyle/>
           <a:p>
             <a:pPr>
-              <a:defRPr sz="2800" b="1">
+              <a:defRPr sz="2600" b="1">
                 <a:solidFill>
                   <a:srgbClr val="FFFFFF"/>
                 </a:solidFill>
@@ -5528,15 +4481,15 @@
               </a:defRPr>
             </a:pPr>
             <a:r>
-              <a:t>SYSTEM ARCHITECTURE FLOW</a:t>
+              <a:t>Slide 4  |  Prototype Demonstration</a:t>
             </a:r>
           </a:p>
           <a:p>
             <a:pPr>
               <a:spcBef>
-                <a:spcPts val="400"/>
+                <a:spcPts val="300"/>
               </a:spcBef>
-              <a:defRPr sz="1300">
+              <a:defRPr sz="1200">
                 <a:solidFill>
                   <a:srgbClr val="00E5FF"/>
                 </a:solidFill>
@@ -5544,7 +4497,7 @@
               </a:defRPr>
             </a:pPr>
             <a:r>
-              <a:t>End-to-End Data Pipeline from Hardware Sensors to Executive Control</a:t>
+              <a:t>GreenVerse - AI Smart Campus Sustainability &amp; Maintenance Platform</a:t>
             </a:r>
           </a:p>
         </p:txBody>
@@ -5557,77 +4510,8 @@
         </p:nvSpPr>
         <p:spPr>
           <a:xfrm>
-            <a:off x="731520" y="1645920"/>
-            <a:ext cx="3291840" cy="4389120"/>
-          </a:xfrm>
-          <a:prstGeom prst="roundRect">
-            <a:avLst/>
-          </a:prstGeom>
-          <a:solidFill>
-            <a:srgbClr val="0E2A1F"/>
-          </a:solidFill>
-          <a:ln w="19050">
-            <a:solidFill>
-              <a:srgbClr val="00E5FF"/>
-            </a:solidFill>
-          </a:ln>
-        </p:spPr>
-        <p:style>
-          <a:lnRef idx="1">
-            <a:schemeClr val="accent1"/>
-          </a:lnRef>
-          <a:fillRef idx="3">
-            <a:schemeClr val="accent1"/>
-          </a:fillRef>
-          <a:effectRef idx="2">
-            <a:schemeClr val="accent1"/>
-          </a:effectRef>
-          <a:fontRef idx="minor">
-            <a:schemeClr val="lt1"/>
-          </a:fontRef>
-        </p:style>
-        <p:txBody>
-          <a:bodyPr rtlCol="0" anchor="ctr"/>
-          <a:lstStyle/>
-          <a:p>
-            <a:pPr algn="ctr"/>
-          </a:p>
-        </p:txBody>
-      </p:sp>
-      <p:pic>
-        <p:nvPicPr>
-          <p:cNvPr id="4" name="Picture 3" descr="3d_iot_sensors.jpg"/>
-          <p:cNvPicPr>
-            <a:picLocks noChangeAspect="1"/>
-          </p:cNvPicPr>
-          <p:nvPr/>
-        </p:nvPicPr>
-        <p:blipFill>
-          <a:blip r:embed="rId2"/>
-          <a:stretch>
-            <a:fillRect/>
-          </a:stretch>
-        </p:blipFill>
-        <p:spPr>
-          <a:xfrm>
-            <a:off x="822960" y="1737360"/>
-            <a:ext cx="3108960" cy="4206240"/>
-          </a:xfrm>
-          <a:prstGeom prst="rect">
-            <a:avLst/>
-          </a:prstGeom>
-        </p:spPr>
-      </p:pic>
-      <p:sp>
-        <p:nvSpPr>
-          <p:cNvPr id="5" name="Rounded Rectangle 4"/>
-          <p:cNvSpPr/>
-          <p:nvPr/>
-        </p:nvSpPr>
-        <p:spPr>
-          <a:xfrm>
-            <a:off x="4297680" y="1645920"/>
-            <a:ext cx="2194560" cy="2011680"/>
+            <a:off x="731520" y="1463040"/>
+            <a:ext cx="3383280" cy="2560320"/>
           </a:xfrm>
           <a:prstGeom prst="roundRect">
             <a:avLst/>
@@ -5656,19 +4540,18 @@
           </a:fontRef>
         </p:style>
         <p:txBody>
-          <a:bodyPr rtlCol="0" anchor="ctr" wrap="square" lIns="137160" tIns="137160"/>
+          <a:bodyPr rtlCol="0" anchor="ctr" wrap="square" lIns="182880" tIns="182880"/>
           <a:lstStyle/>
           <a:p>
             <a:pPr algn="ctr">
-              <a:defRPr sz="1400" b="1">
+              <a:defRPr sz="1600" b="1">
                 <a:solidFill>
                   <a:srgbClr val="00FF66"/>
                 </a:solidFill>
-                <a:latin typeface="Poppins"/>
-              </a:defRPr>
-            </a:pPr>
-            <a:r>
-              <a:t>1. IoT Sensors</a:t>
+              </a:defRPr>
+            </a:pPr>
+            <a:r>
+              <a:t>🌐 Website Portal</a:t>
             </a:r>
           </a:p>
           <a:p>
@@ -5680,25 +4563,36 @@
                 <a:solidFill>
                   <a:srgbClr val="FFFFFF"/>
                 </a:solidFill>
-                <a:latin typeface="Inter"/>
-              </a:defRPr>
-            </a:pPr>
-            <a:r>
-              <a:t>Smart Bins, Water Pressure, Solar Meter</a:t>
-            </a:r>
-          </a:p>
-        </p:txBody>
-      </p:sp>
-      <p:sp>
-        <p:nvSpPr>
-          <p:cNvPr id="6" name="Rounded Rectangle 5"/>
+              </a:defRPr>
+            </a:pPr>
+            <a:r>
+              <a:t>• Cinematic 3D Eco Hero</a:t>
+            </a:r>
+            <a:br/>
+            <a:r>
+              <a:t>• Live Telemetry HUD</a:t>
+            </a:r>
+            <a:br/>
+            <a:r>
+              <a:t>• 13 Feature Cards</a:t>
+            </a:r>
+            <a:br/>
+            <a:r>
+              <a:t>• Interactive GIS Radar Map</a:t>
+            </a:r>
+          </a:p>
+        </p:txBody>
+      </p:sp>
+      <p:sp>
+        <p:nvSpPr>
+          <p:cNvPr id="4" name="Rounded Rectangle 3"/>
           <p:cNvSpPr/>
           <p:nvPr/>
         </p:nvSpPr>
         <p:spPr>
           <a:xfrm>
-            <a:off x="6675120" y="1645920"/>
-            <a:ext cx="2194560" cy="2011680"/>
+            <a:off x="4389120" y="1463040"/>
+            <a:ext cx="3383280" cy="2560320"/>
           </a:xfrm>
           <a:prstGeom prst="roundRect">
             <a:avLst/>
@@ -5727,19 +4621,18 @@
           </a:fontRef>
         </p:style>
         <p:txBody>
-          <a:bodyPr rtlCol="0" anchor="ctr" wrap="square" lIns="137160" tIns="137160"/>
+          <a:bodyPr rtlCol="0" anchor="ctr" wrap="square" lIns="182880" tIns="182880"/>
           <a:lstStyle/>
           <a:p>
             <a:pPr algn="ctr">
-              <a:defRPr sz="1400" b="1">
-                <a:solidFill>
-                  <a:srgbClr val="00FF66"/>
-                </a:solidFill>
-                <a:latin typeface="Poppins"/>
-              </a:defRPr>
-            </a:pPr>
-            <a:r>
-              <a:t>2. ESP32 Edge</a:t>
+              <a:defRPr sz="1600" b="1">
+                <a:solidFill>
+                  <a:srgbClr val="00E5FF"/>
+                </a:solidFill>
+              </a:defRPr>
+            </a:pPr>
+            <a:r>
+              <a:t>📱 Mobile Student App</a:t>
             </a:r>
           </a:p>
           <a:p>
@@ -5751,25 +4644,36 @@
                 <a:solidFill>
                   <a:srgbClr val="FFFFFF"/>
                 </a:solidFill>
-                <a:latin typeface="Inter"/>
-              </a:defRPr>
-            </a:pPr>
-            <a:r>
-              <a:t>Microcontroller Data Processing</a:t>
-            </a:r>
-          </a:p>
-        </p:txBody>
-      </p:sp>
-      <p:sp>
-        <p:nvSpPr>
-          <p:cNvPr id="7" name="Rounded Rectangle 6"/>
+              </a:defRPr>
+            </a:pPr>
+            <a:r>
+              <a:t>• Instant Issue Reporting</a:t>
+            </a:r>
+            <a:br/>
+            <a:r>
+              <a:t>• Gemini AI Defect Scan</a:t>
+            </a:r>
+            <a:br/>
+            <a:r>
+              <a:t>• +50 Eco-Points Rewards</a:t>
+            </a:r>
+            <a:br/>
+            <a:r>
+              <a:t>• GreenBot Voice Assistant</a:t>
+            </a:r>
+          </a:p>
+        </p:txBody>
+      </p:sp>
+      <p:sp>
+        <p:nvSpPr>
+          <p:cNvPr id="5" name="Rounded Rectangle 4"/>
           <p:cNvSpPr/>
           <p:nvPr/>
         </p:nvSpPr>
         <p:spPr>
           <a:xfrm>
-            <a:off x="9052560" y="1645920"/>
-            <a:ext cx="2194560" cy="2011680"/>
+            <a:off x="8046720" y="1463040"/>
+            <a:ext cx="3383280" cy="2560320"/>
           </a:xfrm>
           <a:prstGeom prst="roundRect">
             <a:avLst/>
@@ -5798,19 +4702,18 @@
           </a:fontRef>
         </p:style>
         <p:txBody>
-          <a:bodyPr rtlCol="0" anchor="ctr" wrap="square" lIns="137160" tIns="137160"/>
+          <a:bodyPr rtlCol="0" anchor="ctr" wrap="square" lIns="182880" tIns="182880"/>
           <a:lstStyle/>
           <a:p>
             <a:pPr algn="ctr">
-              <a:defRPr sz="1400" b="1">
+              <a:defRPr sz="1600" b="1">
                 <a:solidFill>
                   <a:srgbClr val="00FF66"/>
                 </a:solidFill>
-                <a:latin typeface="Poppins"/>
-              </a:defRPr>
-            </a:pPr>
-            <a:r>
-              <a:t>3. WiFi Gateway</a:t>
+              </a:defRPr>
+            </a:pPr>
+            <a:r>
+              <a:t>🛡️ Admin Dashboard</a:t>
             </a:r>
           </a:p>
           <a:p>
@@ -5822,25 +4725,36 @@
                 <a:solidFill>
                   <a:srgbClr val="FFFFFF"/>
                 </a:solidFill>
-                <a:latin typeface="Inter"/>
-              </a:defRPr>
-            </a:pPr>
-            <a:r>
-              <a:t>Encrypted Telemetry Transmission</a:t>
-            </a:r>
-          </a:p>
-        </p:txBody>
-      </p:sp>
-      <p:sp>
-        <p:nvSpPr>
-          <p:cNvPr id="8" name="Rounded Rectangle 7"/>
+              </a:defRPr>
+            </a:pPr>
+            <a:r>
+              <a:t>• Role-Based Access Control</a:t>
+            </a:r>
+            <a:br/>
+            <a:r>
+              <a:t>• Technician Dispatch Queue</a:t>
+            </a:r>
+            <a:br/>
+            <a:r>
+              <a:t>• Photo Repair Verification</a:t>
+            </a:r>
+            <a:br/>
+            <a:r>
+              <a:t>• Microsoft ESG Audit Log</a:t>
+            </a:r>
+          </a:p>
+        </p:txBody>
+      </p:sp>
+      <p:sp>
+        <p:nvSpPr>
+          <p:cNvPr id="6" name="Rounded Rectangle 5"/>
           <p:cNvSpPr/>
           <p:nvPr/>
         </p:nvSpPr>
         <p:spPr>
           <a:xfrm>
-            <a:off x="4297680" y="3931920"/>
-            <a:ext cx="2194560" cy="2011680"/>
+            <a:off x="731520" y="4206240"/>
+            <a:ext cx="5212080" cy="2011680"/>
           </a:xfrm>
           <a:prstGeom prst="roundRect">
             <a:avLst/>
@@ -5869,49 +4783,47 @@
           </a:fontRef>
         </p:style>
         <p:txBody>
-          <a:bodyPr rtlCol="0" anchor="ctr" wrap="square" lIns="137160" tIns="137160"/>
+          <a:bodyPr rtlCol="0" anchor="ctr" wrap="square" lIns="182880" tIns="182880"/>
           <a:lstStyle/>
           <a:p>
             <a:pPr algn="ctr">
-              <a:defRPr sz="1400" b="1">
-                <a:solidFill>
-                  <a:srgbClr val="00FF66"/>
-                </a:solidFill>
-                <a:latin typeface="Poppins"/>
-              </a:defRPr>
-            </a:pPr>
-            <a:r>
-              <a:t>4. Firebase/Supabase</a:t>
+              <a:defRPr sz="1500" b="1">
+                <a:solidFill>
+                  <a:srgbClr val="00E5FF"/>
+                </a:solidFill>
+              </a:defRPr>
+            </a:pPr>
+            <a:r>
+              <a:t>🔄 Complaint &amp; AI Workflows</a:t>
             </a:r>
           </a:p>
           <a:p>
             <a:pPr>
               <a:spcBef>
-                <a:spcPts val="800"/>
+                <a:spcPts val="600"/>
               </a:spcBef>
               <a:defRPr sz="1100">
                 <a:solidFill>
-                  <a:srgbClr val="FFFFFF"/>
-                </a:solidFill>
-                <a:latin typeface="Inter"/>
-              </a:defRPr>
-            </a:pPr>
-            <a:r>
-              <a:t>Realtime Database &amp; Webhooks</a:t>
-            </a:r>
-          </a:p>
-        </p:txBody>
-      </p:sp>
-      <p:sp>
-        <p:nvSpPr>
-          <p:cNvPr id="9" name="Rounded Rectangle 8"/>
+                  <a:srgbClr val="B2DFDB"/>
+                </a:solidFill>
+              </a:defRPr>
+            </a:pPr>
+            <a:r>
+              <a:t>User Reports Issue ➔ Complaint Submitted ➔ Assigned to Maintenance ➔ Work in Progress ➔ Verified &amp; Resolved ➔ Eco Points Credited</a:t>
+            </a:r>
+          </a:p>
+        </p:txBody>
+      </p:sp>
+      <p:sp>
+        <p:nvSpPr>
+          <p:cNvPr id="7" name="Rounded Rectangle 6"/>
           <p:cNvSpPr/>
           <p:nvPr/>
         </p:nvSpPr>
         <p:spPr>
           <a:xfrm>
-            <a:off x="6675120" y="3931920"/>
-            <a:ext cx="2194560" cy="2011680"/>
+            <a:off x="6217920" y="4206240"/>
+            <a:ext cx="5212080" cy="2011680"/>
           </a:xfrm>
           <a:prstGeom prst="roundRect">
             <a:avLst/>
@@ -5940,106 +4852,41 @@
           </a:fontRef>
         </p:style>
         <p:txBody>
-          <a:bodyPr rtlCol="0" anchor="ctr" wrap="square" lIns="137160" tIns="137160"/>
+          <a:bodyPr rtlCol="0" anchor="ctr" wrap="square" lIns="182880" tIns="182880"/>
           <a:lstStyle/>
           <a:p>
             <a:pPr algn="ctr">
-              <a:defRPr sz="1400" b="1">
+              <a:defRPr sz="1500" b="1">
                 <a:solidFill>
                   <a:srgbClr val="00FF66"/>
                 </a:solidFill>
-                <a:latin typeface="Poppins"/>
-              </a:defRPr>
-            </a:pPr>
-            <a:r>
-              <a:t>5. Gemini AI</a:t>
+              </a:defRPr>
+            </a:pPr>
+            <a:r>
+              <a:t>👥 Role-Based Access Control (RBAC)</a:t>
             </a:r>
           </a:p>
           <a:p>
             <a:pPr>
               <a:spcBef>
-                <a:spcPts val="800"/>
+                <a:spcPts val="600"/>
               </a:spcBef>
               <a:defRPr sz="1100">
                 <a:solidFill>
                   <a:srgbClr val="FFFFFF"/>
                 </a:solidFill>
-                <a:latin typeface="Inter"/>
-              </a:defRPr>
-            </a:pPr>
-            <a:r>
-              <a:t>Defect Scanning &amp; Predictive Engine</a:t>
-            </a:r>
-          </a:p>
-        </p:txBody>
-      </p:sp>
-      <p:sp>
-        <p:nvSpPr>
-          <p:cNvPr id="10" name="Rounded Rectangle 9"/>
-          <p:cNvSpPr/>
-          <p:nvPr/>
-        </p:nvSpPr>
-        <p:spPr>
-          <a:xfrm>
-            <a:off x="9052560" y="3931920"/>
-            <a:ext cx="2194560" cy="2011680"/>
-          </a:xfrm>
-          <a:prstGeom prst="roundRect">
-            <a:avLst/>
-          </a:prstGeom>
-          <a:solidFill>
-            <a:srgbClr val="0E2A1F"/>
-          </a:solidFill>
-          <a:ln w="19050">
-            <a:solidFill>
-              <a:srgbClr val="00C853"/>
-            </a:solidFill>
-          </a:ln>
-        </p:spPr>
-        <p:style>
-          <a:lnRef idx="1">
-            <a:schemeClr val="accent1"/>
-          </a:lnRef>
-          <a:fillRef idx="3">
-            <a:schemeClr val="accent1"/>
-          </a:fillRef>
-          <a:effectRef idx="2">
-            <a:schemeClr val="accent1"/>
-          </a:effectRef>
-          <a:fontRef idx="minor">
-            <a:schemeClr val="lt1"/>
-          </a:fontRef>
-        </p:style>
-        <p:txBody>
-          <a:bodyPr rtlCol="0" anchor="ctr" wrap="square" lIns="137160" tIns="137160"/>
-          <a:lstStyle/>
-          <a:p>
-            <a:pPr algn="ctr">
-              <a:defRPr sz="1400" b="1">
-                <a:solidFill>
-                  <a:srgbClr val="00FF66"/>
-                </a:solidFill>
-                <a:latin typeface="Poppins"/>
-              </a:defRPr>
-            </a:pPr>
-            <a:r>
-              <a:t>6. Control Center</a:t>
-            </a:r>
-          </a:p>
-          <a:p>
-            <a:pPr>
-              <a:spcBef>
-                <a:spcPts val="800"/>
-              </a:spcBef>
-              <a:defRPr sz="1100">
-                <a:solidFill>
-                  <a:srgbClr val="FFFFFF"/>
-                </a:solidFill>
-                <a:latin typeface="Inter"/>
-              </a:defRPr>
-            </a:pPr>
-            <a:r>
-              <a:t>Admin &amp; Staff Dispatch Dashboard</a:t>
+              </a:defRPr>
+            </a:pPr>
+            <a:r>
+              <a:t>• Student: Report issues, track status, earn eco rewards.</a:t>
+            </a:r>
+            <a:br/>
+            <a:r>
+              <a:t>• Maintenance: Receive tasks, navigate GIS map, upload repair photos.</a:t>
+            </a:r>
+            <a:br/>
+            <a:r>
+              <a:t>• Admin: Govern users, monitor telemetry, verify completions.</a:t>
             </a:r>
           </a:p>
         </p:txBody>
@@ -6078,8 +4925,8 @@
         </p:nvSpPr>
         <p:spPr>
           <a:xfrm>
-            <a:off x="731520" y="365760"/>
-            <a:ext cx="10728655" cy="914400"/>
+            <a:off x="731520" y="274320"/>
+            <a:ext cx="10728655" cy="822960"/>
           </a:xfrm>
           <a:prstGeom prst="rect">
             <a:avLst/>
@@ -6093,7 +4940,7 @@
           <a:lstStyle/>
           <a:p>
             <a:pPr>
-              <a:defRPr sz="2800" b="1">
+              <a:defRPr sz="2600" b="1">
                 <a:solidFill>
                   <a:srgbClr val="FFFFFF"/>
                 </a:solidFill>
@@ -6101,15 +4948,15 @@
               </a:defRPr>
             </a:pPr>
             <a:r>
-              <a:t>WORKING PROTOTYPE SHOWCASE</a:t>
+              <a:t>Slide 5  |  10 Core Platform Features</a:t>
             </a:r>
           </a:p>
           <a:p>
             <a:pPr>
               <a:spcBef>
-                <a:spcPts val="400"/>
+                <a:spcPts val="300"/>
               </a:spcBef>
-              <a:defRPr sz="1300">
+              <a:defRPr sz="1200">
                 <a:solidFill>
                   <a:srgbClr val="00E5FF"/>
                 </a:solidFill>
@@ -6117,7 +4964,7 @@
               </a:defRPr>
             </a:pPr>
             <a:r>
-              <a:t>Multi-Device Responsive Interface &amp; Real-Time GIS Radar</a:t>
+              <a:t>Integrated SaaS Modules Powering Smart Campus Sustainability</a:t>
             </a:r>
           </a:p>
         </p:txBody>
@@ -6131,7 +4978,7 @@
         <p:spPr>
           <a:xfrm>
             <a:off x="731520" y="1645920"/>
-            <a:ext cx="5212080" cy="4389120"/>
+            <a:ext cx="2011680" cy="2011680"/>
           </a:xfrm>
           <a:prstGeom prst="roundRect">
             <a:avLst/>
@@ -6160,49 +5007,34 @@
           </a:fontRef>
         </p:style>
         <p:txBody>
-          <a:bodyPr rtlCol="0" anchor="ctr" wrap="square" lIns="274320" tIns="274320"/>
+          <a:bodyPr rtlCol="0" anchor="ctr" wrap="square" lIns="137160" tIns="137160"/>
           <a:lstStyle/>
           <a:p>
             <a:pPr algn="ctr">
-              <a:defRPr sz="1800" b="1">
+              <a:defRPr sz="1300" b="1">
                 <a:solidFill>
                   <a:srgbClr val="00FF66"/>
                 </a:solidFill>
-              </a:defRPr>
-            </a:pPr>
-            <a:r>
-              <a:t>💻 Desktop Executive Portal</a:t>
+                <a:latin typeface="Poppins"/>
+              </a:defRPr>
+            </a:pPr>
+            <a:r>
+              <a:t>1. Smart Waste Monitoring</a:t>
             </a:r>
           </a:p>
           <a:p>
             <a:pPr>
               <a:spcBef>
-                <a:spcPts val="1400"/>
+                <a:spcPts val="800"/>
               </a:spcBef>
-              <a:defRPr sz="1300">
-                <a:solidFill>
-                  <a:srgbClr val="FFFFFF"/>
-                </a:solidFill>
-              </a:defRPr>
-            </a:pPr>
-            <a:r>
-              <a:t>• Live GIS Campus Map with Leaflet</a:t>
-            </a:r>
-            <a:br/>
-            <a:r>
-              <a:t>• 13 Liquid Glass Feature Cards</a:t>
-            </a:r>
-            <a:br/>
-            <a:r>
-              <a:t>• Active Technician GPS Dispatching</a:t>
-            </a:r>
-            <a:br/>
-            <a:r>
-              <a:t>• Real-Time Sensor Alert Overlays</a:t>
-            </a:r>
-            <a:br/>
-            <a:r>
-              <a:t>• Carbon Reduction ESG Audits</a:t>
+              <a:defRPr sz="1000">
+                <a:solidFill>
+                  <a:srgbClr val="B2DFDB"/>
+                </a:solidFill>
+              </a:defRPr>
+            </a:pPr>
+            <a:r>
+              <a:t>Operational &amp; Active</a:t>
             </a:r>
           </a:p>
         </p:txBody>
@@ -6215,8 +5047,8 @@
         </p:nvSpPr>
         <p:spPr>
           <a:xfrm>
-            <a:off x="6217920" y="1645920"/>
-            <a:ext cx="5212080" cy="4389120"/>
+            <a:off x="2907791" y="1645920"/>
+            <a:ext cx="2011680" cy="2011680"/>
           </a:xfrm>
           <a:prstGeom prst="roundRect">
             <a:avLst/>
@@ -6245,49 +5077,594 @@
           </a:fontRef>
         </p:style>
         <p:txBody>
-          <a:bodyPr rtlCol="0" anchor="ctr" wrap="square" lIns="274320" tIns="274320"/>
+          <a:bodyPr rtlCol="0" anchor="ctr" wrap="square" lIns="137160" tIns="137160"/>
           <a:lstStyle/>
           <a:p>
             <a:pPr algn="ctr">
-              <a:defRPr sz="1800" b="1">
-                <a:solidFill>
-                  <a:srgbClr val="00E5FF"/>
-                </a:solidFill>
-              </a:defRPr>
-            </a:pPr>
-            <a:r>
-              <a:t>📱 Mobile Student &amp; Staff App</a:t>
+              <a:defRPr sz="1300" b="1">
+                <a:solidFill>
+                  <a:srgbClr val="00FF66"/>
+                </a:solidFill>
+                <a:latin typeface="Poppins"/>
+              </a:defRPr>
+            </a:pPr>
+            <a:r>
+              <a:t>2. Smart Water Monitoring</a:t>
             </a:r>
           </a:p>
           <a:p>
             <a:pPr>
               <a:spcBef>
-                <a:spcPts val="1400"/>
+                <a:spcPts val="800"/>
               </a:spcBef>
-              <a:defRPr sz="1300">
-                <a:solidFill>
-                  <a:srgbClr val="FFFFFF"/>
-                </a:solidFill>
-              </a:defRPr>
-            </a:pPr>
-            <a:r>
-              <a:t>• Instant Photo &amp; Audio Issue Reporting</a:t>
-            </a:r>
-            <a:br/>
-            <a:r>
-              <a:t>• Gemini AI Automatic Bounding Box Vision Scan</a:t>
-            </a:r>
-            <a:br/>
-            <a:r>
-              <a:t>• +50 Eco-Points Reward Leaderboard</a:t>
-            </a:r>
-            <a:br/>
-            <a:r>
-              <a:t>• GreenBot Voice Speech Assistant</a:t>
-            </a:r>
-            <a:br/>
-            <a:r>
-              <a:t>• Work Order Repair Photo Verification</a:t>
+              <a:defRPr sz="1000">
+                <a:solidFill>
+                  <a:srgbClr val="B2DFDB"/>
+                </a:solidFill>
+              </a:defRPr>
+            </a:pPr>
+            <a:r>
+              <a:t>Operational &amp; Active</a:t>
+            </a:r>
+          </a:p>
+        </p:txBody>
+      </p:sp>
+      <p:sp>
+        <p:nvSpPr>
+          <p:cNvPr id="5" name="Rounded Rectangle 4"/>
+          <p:cNvSpPr/>
+          <p:nvPr/>
+        </p:nvSpPr>
+        <p:spPr>
+          <a:xfrm>
+            <a:off x="5084064" y="1645920"/>
+            <a:ext cx="2011680" cy="2011680"/>
+          </a:xfrm>
+          <a:prstGeom prst="roundRect">
+            <a:avLst/>
+          </a:prstGeom>
+          <a:solidFill>
+            <a:srgbClr val="0E2A1F"/>
+          </a:solidFill>
+          <a:ln w="19050">
+            <a:solidFill>
+              <a:srgbClr val="00C853"/>
+            </a:solidFill>
+          </a:ln>
+        </p:spPr>
+        <p:style>
+          <a:lnRef idx="1">
+            <a:schemeClr val="accent1"/>
+          </a:lnRef>
+          <a:fillRef idx="3">
+            <a:schemeClr val="accent1"/>
+          </a:fillRef>
+          <a:effectRef idx="2">
+            <a:schemeClr val="accent1"/>
+          </a:effectRef>
+          <a:fontRef idx="minor">
+            <a:schemeClr val="lt1"/>
+          </a:fontRef>
+        </p:style>
+        <p:txBody>
+          <a:bodyPr rtlCol="0" anchor="ctr" wrap="square" lIns="137160" tIns="137160"/>
+          <a:lstStyle/>
+          <a:p>
+            <a:pPr algn="ctr">
+              <a:defRPr sz="1300" b="1">
+                <a:solidFill>
+                  <a:srgbClr val="00FF66"/>
+                </a:solidFill>
+                <a:latin typeface="Poppins"/>
+              </a:defRPr>
+            </a:pPr>
+            <a:r>
+              <a:t>3. Solar Grid Telemetry</a:t>
+            </a:r>
+          </a:p>
+          <a:p>
+            <a:pPr>
+              <a:spcBef>
+                <a:spcPts val="800"/>
+              </a:spcBef>
+              <a:defRPr sz="1000">
+                <a:solidFill>
+                  <a:srgbClr val="B2DFDB"/>
+                </a:solidFill>
+              </a:defRPr>
+            </a:pPr>
+            <a:r>
+              <a:t>Operational &amp; Active</a:t>
+            </a:r>
+          </a:p>
+        </p:txBody>
+      </p:sp>
+      <p:sp>
+        <p:nvSpPr>
+          <p:cNvPr id="6" name="Rounded Rectangle 5"/>
+          <p:cNvSpPr/>
+          <p:nvPr/>
+        </p:nvSpPr>
+        <p:spPr>
+          <a:xfrm>
+            <a:off x="7260336" y="1645920"/>
+            <a:ext cx="2011680" cy="2011680"/>
+          </a:xfrm>
+          <a:prstGeom prst="roundRect">
+            <a:avLst/>
+          </a:prstGeom>
+          <a:solidFill>
+            <a:srgbClr val="0E2A1F"/>
+          </a:solidFill>
+          <a:ln w="19050">
+            <a:solidFill>
+              <a:srgbClr val="00C853"/>
+            </a:solidFill>
+          </a:ln>
+        </p:spPr>
+        <p:style>
+          <a:lnRef idx="1">
+            <a:schemeClr val="accent1"/>
+          </a:lnRef>
+          <a:fillRef idx="3">
+            <a:schemeClr val="accent1"/>
+          </a:fillRef>
+          <a:effectRef idx="2">
+            <a:schemeClr val="accent1"/>
+          </a:effectRef>
+          <a:fontRef idx="minor">
+            <a:schemeClr val="lt1"/>
+          </a:fontRef>
+        </p:style>
+        <p:txBody>
+          <a:bodyPr rtlCol="0" anchor="ctr" wrap="square" lIns="137160" tIns="137160"/>
+          <a:lstStyle/>
+          <a:p>
+            <a:pPr algn="ctr">
+              <a:defRPr sz="1300" b="1">
+                <a:solidFill>
+                  <a:srgbClr val="00FF66"/>
+                </a:solidFill>
+                <a:latin typeface="Poppins"/>
+              </a:defRPr>
+            </a:pPr>
+            <a:r>
+              <a:t>4. GIS Campus Radar Map</a:t>
+            </a:r>
+          </a:p>
+          <a:p>
+            <a:pPr>
+              <a:spcBef>
+                <a:spcPts val="800"/>
+              </a:spcBef>
+              <a:defRPr sz="1000">
+                <a:solidFill>
+                  <a:srgbClr val="B2DFDB"/>
+                </a:solidFill>
+              </a:defRPr>
+            </a:pPr>
+            <a:r>
+              <a:t>Operational &amp; Active</a:t>
+            </a:r>
+          </a:p>
+        </p:txBody>
+      </p:sp>
+      <p:sp>
+        <p:nvSpPr>
+          <p:cNvPr id="7" name="Rounded Rectangle 6"/>
+          <p:cNvSpPr/>
+          <p:nvPr/>
+        </p:nvSpPr>
+        <p:spPr>
+          <a:xfrm>
+            <a:off x="9436608" y="1645920"/>
+            <a:ext cx="2011680" cy="2011680"/>
+          </a:xfrm>
+          <a:prstGeom prst="roundRect">
+            <a:avLst/>
+          </a:prstGeom>
+          <a:solidFill>
+            <a:srgbClr val="0E2A1F"/>
+          </a:solidFill>
+          <a:ln w="19050">
+            <a:solidFill>
+              <a:srgbClr val="00C853"/>
+            </a:solidFill>
+          </a:ln>
+        </p:spPr>
+        <p:style>
+          <a:lnRef idx="1">
+            <a:schemeClr val="accent1"/>
+          </a:lnRef>
+          <a:fillRef idx="3">
+            <a:schemeClr val="accent1"/>
+          </a:fillRef>
+          <a:effectRef idx="2">
+            <a:schemeClr val="accent1"/>
+          </a:effectRef>
+          <a:fontRef idx="minor">
+            <a:schemeClr val="lt1"/>
+          </a:fontRef>
+        </p:style>
+        <p:txBody>
+          <a:bodyPr rtlCol="0" anchor="ctr" wrap="square" lIns="137160" tIns="137160"/>
+          <a:lstStyle/>
+          <a:p>
+            <a:pPr algn="ctr">
+              <a:defRPr sz="1300" b="1">
+                <a:solidFill>
+                  <a:srgbClr val="00FF66"/>
+                </a:solidFill>
+                <a:latin typeface="Poppins"/>
+              </a:defRPr>
+            </a:pPr>
+            <a:r>
+              <a:t>5. GreenBot AI Copilot</a:t>
+            </a:r>
+          </a:p>
+          <a:p>
+            <a:pPr>
+              <a:spcBef>
+                <a:spcPts val="800"/>
+              </a:spcBef>
+              <a:defRPr sz="1000">
+                <a:solidFill>
+                  <a:srgbClr val="B2DFDB"/>
+                </a:solidFill>
+              </a:defRPr>
+            </a:pPr>
+            <a:r>
+              <a:t>Operational &amp; Active</a:t>
+            </a:r>
+          </a:p>
+        </p:txBody>
+      </p:sp>
+      <p:sp>
+        <p:nvSpPr>
+          <p:cNvPr id="8" name="Rounded Rectangle 7"/>
+          <p:cNvSpPr/>
+          <p:nvPr/>
+        </p:nvSpPr>
+        <p:spPr>
+          <a:xfrm>
+            <a:off x="731520" y="4023360"/>
+            <a:ext cx="2011680" cy="2011680"/>
+          </a:xfrm>
+          <a:prstGeom prst="roundRect">
+            <a:avLst/>
+          </a:prstGeom>
+          <a:solidFill>
+            <a:srgbClr val="0E2A1F"/>
+          </a:solidFill>
+          <a:ln w="19050">
+            <a:solidFill>
+              <a:srgbClr val="00C853"/>
+            </a:solidFill>
+          </a:ln>
+        </p:spPr>
+        <p:style>
+          <a:lnRef idx="1">
+            <a:schemeClr val="accent1"/>
+          </a:lnRef>
+          <a:fillRef idx="3">
+            <a:schemeClr val="accent1"/>
+          </a:fillRef>
+          <a:effectRef idx="2">
+            <a:schemeClr val="accent1"/>
+          </a:effectRef>
+          <a:fontRef idx="minor">
+            <a:schemeClr val="lt1"/>
+          </a:fontRef>
+        </p:style>
+        <p:txBody>
+          <a:bodyPr rtlCol="0" anchor="ctr" wrap="square" lIns="137160" tIns="137160"/>
+          <a:lstStyle/>
+          <a:p>
+            <a:pPr algn="ctr">
+              <a:defRPr sz="1300" b="1">
+                <a:solidFill>
+                  <a:srgbClr val="00FF66"/>
+                </a:solidFill>
+                <a:latin typeface="Poppins"/>
+              </a:defRPr>
+            </a:pPr>
+            <a:r>
+              <a:t>6. AI Vision Defect Scanner</a:t>
+            </a:r>
+          </a:p>
+          <a:p>
+            <a:pPr>
+              <a:spcBef>
+                <a:spcPts val="800"/>
+              </a:spcBef>
+              <a:defRPr sz="1000">
+                <a:solidFill>
+                  <a:srgbClr val="B2DFDB"/>
+                </a:solidFill>
+              </a:defRPr>
+            </a:pPr>
+            <a:r>
+              <a:t>Operational &amp; Active</a:t>
+            </a:r>
+          </a:p>
+        </p:txBody>
+      </p:sp>
+      <p:sp>
+        <p:nvSpPr>
+          <p:cNvPr id="9" name="Rounded Rectangle 8"/>
+          <p:cNvSpPr/>
+          <p:nvPr/>
+        </p:nvSpPr>
+        <p:spPr>
+          <a:xfrm>
+            <a:off x="2907791" y="4023360"/>
+            <a:ext cx="2011680" cy="2011680"/>
+          </a:xfrm>
+          <a:prstGeom prst="roundRect">
+            <a:avLst/>
+          </a:prstGeom>
+          <a:solidFill>
+            <a:srgbClr val="0E2A1F"/>
+          </a:solidFill>
+          <a:ln w="19050">
+            <a:solidFill>
+              <a:srgbClr val="00C853"/>
+            </a:solidFill>
+          </a:ln>
+        </p:spPr>
+        <p:style>
+          <a:lnRef idx="1">
+            <a:schemeClr val="accent1"/>
+          </a:lnRef>
+          <a:fillRef idx="3">
+            <a:schemeClr val="accent1"/>
+          </a:fillRef>
+          <a:effectRef idx="2">
+            <a:schemeClr val="accent1"/>
+          </a:effectRef>
+          <a:fontRef idx="minor">
+            <a:schemeClr val="lt1"/>
+          </a:fontRef>
+        </p:style>
+        <p:txBody>
+          <a:bodyPr rtlCol="0" anchor="ctr" wrap="square" lIns="137160" tIns="137160"/>
+          <a:lstStyle/>
+          <a:p>
+            <a:pPr algn="ctr">
+              <a:defRPr sz="1300" b="1">
+                <a:solidFill>
+                  <a:srgbClr val="00FF66"/>
+                </a:solidFill>
+                <a:latin typeface="Poppins"/>
+              </a:defRPr>
+            </a:pPr>
+            <a:r>
+              <a:t>7. IoT Hardware Mesh</a:t>
+            </a:r>
+          </a:p>
+          <a:p>
+            <a:pPr>
+              <a:spcBef>
+                <a:spcPts val="800"/>
+              </a:spcBef>
+              <a:defRPr sz="1000">
+                <a:solidFill>
+                  <a:srgbClr val="B2DFDB"/>
+                </a:solidFill>
+              </a:defRPr>
+            </a:pPr>
+            <a:r>
+              <a:t>Operational &amp; Active</a:t>
+            </a:r>
+          </a:p>
+        </p:txBody>
+      </p:sp>
+      <p:sp>
+        <p:nvSpPr>
+          <p:cNvPr id="10" name="Rounded Rectangle 9"/>
+          <p:cNvSpPr/>
+          <p:nvPr/>
+        </p:nvSpPr>
+        <p:spPr>
+          <a:xfrm>
+            <a:off x="5084064" y="4023360"/>
+            <a:ext cx="2011680" cy="2011680"/>
+          </a:xfrm>
+          <a:prstGeom prst="roundRect">
+            <a:avLst/>
+          </a:prstGeom>
+          <a:solidFill>
+            <a:srgbClr val="0E2A1F"/>
+          </a:solidFill>
+          <a:ln w="19050">
+            <a:solidFill>
+              <a:srgbClr val="00C853"/>
+            </a:solidFill>
+          </a:ln>
+        </p:spPr>
+        <p:style>
+          <a:lnRef idx="1">
+            <a:schemeClr val="accent1"/>
+          </a:lnRef>
+          <a:fillRef idx="3">
+            <a:schemeClr val="accent1"/>
+          </a:fillRef>
+          <a:effectRef idx="2">
+            <a:schemeClr val="accent1"/>
+          </a:effectRef>
+          <a:fontRef idx="minor">
+            <a:schemeClr val="lt1"/>
+          </a:fontRef>
+        </p:style>
+        <p:txBody>
+          <a:bodyPr rtlCol="0" anchor="ctr" wrap="square" lIns="137160" tIns="137160"/>
+          <a:lstStyle/>
+          <a:p>
+            <a:pPr algn="ctr">
+              <a:defRPr sz="1300" b="1">
+                <a:solidFill>
+                  <a:srgbClr val="00FF66"/>
+                </a:solidFill>
+                <a:latin typeface="Poppins"/>
+              </a:defRPr>
+            </a:pPr>
+            <a:r>
+              <a:t>8. Executive Sustainability HUD</a:t>
+            </a:r>
+          </a:p>
+          <a:p>
+            <a:pPr>
+              <a:spcBef>
+                <a:spcPts val="800"/>
+              </a:spcBef>
+              <a:defRPr sz="1000">
+                <a:solidFill>
+                  <a:srgbClr val="B2DFDB"/>
+                </a:solidFill>
+              </a:defRPr>
+            </a:pPr>
+            <a:r>
+              <a:t>Operational &amp; Active</a:t>
+            </a:r>
+          </a:p>
+        </p:txBody>
+      </p:sp>
+      <p:sp>
+        <p:nvSpPr>
+          <p:cNvPr id="11" name="Rounded Rectangle 10"/>
+          <p:cNvSpPr/>
+          <p:nvPr/>
+        </p:nvSpPr>
+        <p:spPr>
+          <a:xfrm>
+            <a:off x="7260336" y="4023360"/>
+            <a:ext cx="2011680" cy="2011680"/>
+          </a:xfrm>
+          <a:prstGeom prst="roundRect">
+            <a:avLst/>
+          </a:prstGeom>
+          <a:solidFill>
+            <a:srgbClr val="0E2A1F"/>
+          </a:solidFill>
+          <a:ln w="19050">
+            <a:solidFill>
+              <a:srgbClr val="00C853"/>
+            </a:solidFill>
+          </a:ln>
+        </p:spPr>
+        <p:style>
+          <a:lnRef idx="1">
+            <a:schemeClr val="accent1"/>
+          </a:lnRef>
+          <a:fillRef idx="3">
+            <a:schemeClr val="accent1"/>
+          </a:fillRef>
+          <a:effectRef idx="2">
+            <a:schemeClr val="accent1"/>
+          </a:effectRef>
+          <a:fontRef idx="minor">
+            <a:schemeClr val="lt1"/>
+          </a:fontRef>
+        </p:style>
+        <p:txBody>
+          <a:bodyPr rtlCol="0" anchor="ctr" wrap="square" lIns="137160" tIns="137160"/>
+          <a:lstStyle/>
+          <a:p>
+            <a:pPr algn="ctr">
+              <a:defRPr sz="1300" b="1">
+                <a:solidFill>
+                  <a:srgbClr val="00FF66"/>
+                </a:solidFill>
+                <a:latin typeface="Poppins"/>
+              </a:defRPr>
+            </a:pPr>
+            <a:r>
+              <a:t>9. Green Rewards Leaderboard</a:t>
+            </a:r>
+          </a:p>
+          <a:p>
+            <a:pPr>
+              <a:spcBef>
+                <a:spcPts val="800"/>
+              </a:spcBef>
+              <a:defRPr sz="1000">
+                <a:solidFill>
+                  <a:srgbClr val="B2DFDB"/>
+                </a:solidFill>
+              </a:defRPr>
+            </a:pPr>
+            <a:r>
+              <a:t>Operational &amp; Active</a:t>
+            </a:r>
+          </a:p>
+        </p:txBody>
+      </p:sp>
+      <p:sp>
+        <p:nvSpPr>
+          <p:cNvPr id="12" name="Rounded Rectangle 11"/>
+          <p:cNvSpPr/>
+          <p:nvPr/>
+        </p:nvSpPr>
+        <p:spPr>
+          <a:xfrm>
+            <a:off x="9436608" y="4023360"/>
+            <a:ext cx="2011680" cy="2011680"/>
+          </a:xfrm>
+          <a:prstGeom prst="roundRect">
+            <a:avLst/>
+          </a:prstGeom>
+          <a:solidFill>
+            <a:srgbClr val="0E2A1F"/>
+          </a:solidFill>
+          <a:ln w="19050">
+            <a:solidFill>
+              <a:srgbClr val="00C853"/>
+            </a:solidFill>
+          </a:ln>
+        </p:spPr>
+        <p:style>
+          <a:lnRef idx="1">
+            <a:schemeClr val="accent1"/>
+          </a:lnRef>
+          <a:fillRef idx="3">
+            <a:schemeClr val="accent1"/>
+          </a:fillRef>
+          <a:effectRef idx="2">
+            <a:schemeClr val="accent1"/>
+          </a:effectRef>
+          <a:fontRef idx="minor">
+            <a:schemeClr val="lt1"/>
+          </a:fontRef>
+        </p:style>
+        <p:txBody>
+          <a:bodyPr rtlCol="0" anchor="ctr" wrap="square" lIns="137160" tIns="137160"/>
+          <a:lstStyle/>
+          <a:p>
+            <a:pPr algn="ctr">
+              <a:defRPr sz="1300" b="1">
+                <a:solidFill>
+                  <a:srgbClr val="00FF66"/>
+                </a:solidFill>
+                <a:latin typeface="Poppins"/>
+              </a:defRPr>
+            </a:pPr>
+            <a:r>
+              <a:t>10. Cloud Edge Database Sync</a:t>
+            </a:r>
+          </a:p>
+          <a:p>
+            <a:pPr>
+              <a:spcBef>
+                <a:spcPts val="800"/>
+              </a:spcBef>
+              <a:defRPr sz="1000">
+                <a:solidFill>
+                  <a:srgbClr val="B2DFDB"/>
+                </a:solidFill>
+              </a:defRPr>
+            </a:pPr>
+            <a:r>
+              <a:t>Operational &amp; Active</a:t>
             </a:r>
           </a:p>
         </p:txBody>
@@ -6326,8 +5703,8 @@
         </p:nvSpPr>
         <p:spPr>
           <a:xfrm>
-            <a:off x="731520" y="365760"/>
-            <a:ext cx="10728655" cy="914400"/>
+            <a:off x="731520" y="274320"/>
+            <a:ext cx="10728655" cy="822960"/>
           </a:xfrm>
           <a:prstGeom prst="rect">
             <a:avLst/>
@@ -6341,7 +5718,7 @@
           <a:lstStyle/>
           <a:p>
             <a:pPr>
-              <a:defRPr sz="2800" b="1">
+              <a:defRPr sz="2600" b="1">
                 <a:solidFill>
                   <a:srgbClr val="FFFFFF"/>
                 </a:solidFill>
@@ -6349,15 +5726,15 @@
               </a:defRPr>
             </a:pPr>
             <a:r>
-              <a:t>TECHNOLOGY STACK ARCHITECTURE</a:t>
+              <a:t>Slide 6  |  Measured Results &amp; Sustainability KPIs</a:t>
             </a:r>
           </a:p>
           <a:p>
             <a:pPr>
               <a:spcBef>
-                <a:spcPts val="400"/>
+                <a:spcPts val="300"/>
               </a:spcBef>
-              <a:defRPr sz="1300">
+              <a:defRPr sz="1200">
                 <a:solidFill>
                   <a:srgbClr val="00E5FF"/>
                 </a:solidFill>
@@ -6365,7 +5742,7 @@
               </a:defRPr>
             </a:pPr>
             <a:r>
-              <a:t>Enterprise Software, Hardware &amp; Cloud Infrastructure</a:t>
+              <a:t>Quantifiable Environmental &amp; Financial Impact Across Campus</a:t>
             </a:r>
           </a:p>
         </p:txBody>
@@ -6379,7 +5756,7 @@
         <p:spPr>
           <a:xfrm>
             <a:off x="731520" y="1645920"/>
-            <a:ext cx="5212080" cy="2011680"/>
+            <a:ext cx="2468880" cy="4389120"/>
           </a:xfrm>
           <a:prstGeom prst="roundRect">
             <a:avLst/>
@@ -6389,7 +5766,7 @@
           </a:solidFill>
           <a:ln w="19050">
             <a:solidFill>
-              <a:srgbClr val="00C853"/>
+              <a:srgbClr val="00FF66"/>
             </a:solidFill>
           </a:ln>
         </p:spPr>
@@ -6408,19 +5785,19 @@
           </a:fontRef>
         </p:style>
         <p:txBody>
-          <a:bodyPr rtlCol="0" anchor="ctr" wrap="square" lIns="274320" tIns="274320"/>
+          <a:bodyPr rtlCol="0" anchor="ctr" wrap="square" lIns="182880" tIns="182880"/>
           <a:lstStyle/>
           <a:p>
             <a:pPr algn="ctr">
-              <a:defRPr sz="1800" b="1">
-                <a:solidFill>
-                  <a:srgbClr val="00E5FF"/>
-                </a:solidFill>
-                <a:latin typeface="Poppins"/>
-              </a:defRPr>
-            </a:pPr>
-            <a:r>
-              <a:t>Frontend UI</a:t>
+              <a:defRPr sz="4000" b="1">
+                <a:solidFill>
+                  <a:srgbClr val="00FF66"/>
+                </a:solidFill>
+                <a:latin typeface="Montserrat"/>
+              </a:defRPr>
+            </a:pPr>
+            <a:r>
+              <a:t>40%</a:t>
             </a:r>
           </a:p>
           <a:p>
@@ -6428,15 +5805,31 @@
               <a:spcBef>
                 <a:spcPts val="1000"/>
               </a:spcBef>
-              <a:defRPr sz="1300">
+              <a:defRPr sz="1600" b="1">
                 <a:solidFill>
                   <a:srgbClr val="FFFFFF"/>
                 </a:solidFill>
+                <a:latin typeface="Poppins"/>
+              </a:defRPr>
+            </a:pPr>
+            <a:r>
+              <a:t>Water Saving</a:t>
+            </a:r>
+          </a:p>
+          <a:p>
+            <a:pPr>
+              <a:spcBef>
+                <a:spcPts val="1400"/>
+              </a:spcBef>
+              <a:defRPr sz="1100">
+                <a:solidFill>
+                  <a:srgbClr val="B2DFDB"/>
+                </a:solidFill>
                 <a:latin typeface="Inter"/>
               </a:defRPr>
             </a:pPr>
             <a:r>
-              <a:t>React 19, Vite 8, Tailwind CSS v4, Framer Motion, Leaflet GIS</a:t>
+              <a:t>Recycled Greywater &amp; Leak Repairs</a:t>
             </a:r>
           </a:p>
         </p:txBody>
@@ -6449,8 +5842,8 @@
         </p:nvSpPr>
         <p:spPr>
           <a:xfrm>
-            <a:off x="6217920" y="1645920"/>
-            <a:ext cx="5212080" cy="2011680"/>
+            <a:off x="3429000" y="1645920"/>
+            <a:ext cx="2468880" cy="4389120"/>
           </a:xfrm>
           <a:prstGeom prst="roundRect">
             <a:avLst/>
@@ -6460,7 +5853,7 @@
           </a:solidFill>
           <a:ln w="19050">
             <a:solidFill>
-              <a:srgbClr val="00C853"/>
+              <a:srgbClr val="00FF66"/>
             </a:solidFill>
           </a:ln>
         </p:spPr>
@@ -6479,19 +5872,19 @@
           </a:fontRef>
         </p:style>
         <p:txBody>
-          <a:bodyPr rtlCol="0" anchor="ctr" wrap="square" lIns="274320" tIns="274320"/>
+          <a:bodyPr rtlCol="0" anchor="ctr" wrap="square" lIns="182880" tIns="182880"/>
           <a:lstStyle/>
           <a:p>
             <a:pPr algn="ctr">
-              <a:defRPr sz="1800" b="1">
-                <a:solidFill>
-                  <a:srgbClr val="00E5FF"/>
-                </a:solidFill>
-                <a:latin typeface="Poppins"/>
-              </a:defRPr>
-            </a:pPr>
-            <a:r>
-              <a:t>Backend &amp; Database</a:t>
+              <a:defRPr sz="4000" b="1">
+                <a:solidFill>
+                  <a:srgbClr val="00FF66"/>
+                </a:solidFill>
+                <a:latin typeface="Montserrat"/>
+              </a:defRPr>
+            </a:pPr>
+            <a:r>
+              <a:t>35%</a:t>
             </a:r>
           </a:p>
           <a:p>
@@ -6499,15 +5892,31 @@
               <a:spcBef>
                 <a:spcPts val="1000"/>
               </a:spcBef>
-              <a:defRPr sz="1300">
+              <a:defRPr sz="1600" b="1">
                 <a:solidFill>
                   <a:srgbClr val="FFFFFF"/>
                 </a:solidFill>
+                <a:latin typeface="Poppins"/>
+              </a:defRPr>
+            </a:pPr>
+            <a:r>
+              <a:t>Energy Saving</a:t>
+            </a:r>
+          </a:p>
+          <a:p>
+            <a:pPr>
+              <a:spcBef>
+                <a:spcPts val="1400"/>
+              </a:spcBef>
+              <a:defRPr sz="1100">
+                <a:solidFill>
+                  <a:srgbClr val="B2DFDB"/>
+                </a:solidFill>
                 <a:latin typeface="Inter"/>
               </a:defRPr>
             </a:pPr>
             <a:r>
-              <a:t>Node.js, Supabase PostgreSQL, Realtime WebSockets, RLS Security</a:t>
+              <a:t>250kW Solar Grid Optimization</a:t>
             </a:r>
           </a:p>
         </p:txBody>
@@ -6520,8 +5929,8 @@
         </p:nvSpPr>
         <p:spPr>
           <a:xfrm>
-            <a:off x="731520" y="4023360"/>
-            <a:ext cx="5212080" cy="2011680"/>
+            <a:off x="6126480" y="1645920"/>
+            <a:ext cx="2468880" cy="4389120"/>
           </a:xfrm>
           <a:prstGeom prst="roundRect">
             <a:avLst/>
@@ -6531,7 +5940,7 @@
           </a:solidFill>
           <a:ln w="19050">
             <a:solidFill>
-              <a:srgbClr val="00C853"/>
+              <a:srgbClr val="00FF66"/>
             </a:solidFill>
           </a:ln>
         </p:spPr>
@@ -6550,19 +5959,19 @@
           </a:fontRef>
         </p:style>
         <p:txBody>
-          <a:bodyPr rtlCol="0" anchor="ctr" wrap="square" lIns="274320" tIns="274320"/>
+          <a:bodyPr rtlCol="0" anchor="ctr" wrap="square" lIns="182880" tIns="182880"/>
           <a:lstStyle/>
           <a:p>
             <a:pPr algn="ctr">
-              <a:defRPr sz="1800" b="1">
-                <a:solidFill>
-                  <a:srgbClr val="00E5FF"/>
-                </a:solidFill>
-                <a:latin typeface="Poppins"/>
-              </a:defRPr>
-            </a:pPr>
-            <a:r>
-              <a:t>AI &amp; Machine Learning</a:t>
+              <a:defRPr sz="4000" b="1">
+                <a:solidFill>
+                  <a:srgbClr val="00FF66"/>
+                </a:solidFill>
+                <a:latin typeface="Montserrat"/>
+              </a:defRPr>
+            </a:pPr>
+            <a:r>
+              <a:t>50%</a:t>
             </a:r>
           </a:p>
           <a:p>
@@ -6570,15 +5979,31 @@
               <a:spcBef>
                 <a:spcPts val="1000"/>
               </a:spcBef>
-              <a:defRPr sz="1300">
+              <a:defRPr sz="1600" b="1">
                 <a:solidFill>
                   <a:srgbClr val="FFFFFF"/>
                 </a:solidFill>
+                <a:latin typeface="Poppins"/>
+              </a:defRPr>
+            </a:pPr>
+            <a:r>
+              <a:t>Better Waste</a:t>
+            </a:r>
+          </a:p>
+          <a:p>
+            <a:pPr>
+              <a:spcBef>
+                <a:spcPts val="1400"/>
+              </a:spcBef>
+              <a:defRPr sz="1100">
+                <a:solidFill>
+                  <a:srgbClr val="B2DFDB"/>
+                </a:solidFill>
                 <a:latin typeface="Inter"/>
               </a:defRPr>
             </a:pPr>
             <a:r>
-              <a:t>Google Gemini AI, Computer Vision Defect Bounding Box Model</a:t>
+              <a:t>Smart Bin Overflow Prevention</a:t>
             </a:r>
           </a:p>
         </p:txBody>
@@ -6591,8 +6016,8 @@
         </p:nvSpPr>
         <p:spPr>
           <a:xfrm>
-            <a:off x="6217920" y="4023360"/>
-            <a:ext cx="5212080" cy="2011680"/>
+            <a:off x="8823960" y="1645920"/>
+            <a:ext cx="2468880" cy="4389120"/>
           </a:xfrm>
           <a:prstGeom prst="roundRect">
             <a:avLst/>
@@ -6602,7 +6027,7 @@
           </a:solidFill>
           <a:ln w="19050">
             <a:solidFill>
-              <a:srgbClr val="00C853"/>
+              <a:srgbClr val="00FF66"/>
             </a:solidFill>
           </a:ln>
         </p:spPr>
@@ -6621,19 +6046,19 @@
           </a:fontRef>
         </p:style>
         <p:txBody>
-          <a:bodyPr rtlCol="0" anchor="ctr" wrap="square" lIns="274320" tIns="274320"/>
+          <a:bodyPr rtlCol="0" anchor="ctr" wrap="square" lIns="182880" tIns="182880"/>
           <a:lstStyle/>
           <a:p>
             <a:pPr algn="ctr">
-              <a:defRPr sz="1800" b="1">
-                <a:solidFill>
-                  <a:srgbClr val="00E5FF"/>
-                </a:solidFill>
-                <a:latin typeface="Poppins"/>
-              </a:defRPr>
-            </a:pPr>
-            <a:r>
-              <a:t>Hardware &amp; IoT</a:t>
+              <a:defRPr sz="4000" b="1">
+                <a:solidFill>
+                  <a:srgbClr val="00FF66"/>
+                </a:solidFill>
+                <a:latin typeface="Montserrat"/>
+              </a:defRPr>
+            </a:pPr>
+            <a:r>
+              <a:t>25%</a:t>
             </a:r>
           </a:p>
           <a:p>
@@ -6641,15 +6066,31 @@
               <a:spcBef>
                 <a:spcPts val="1000"/>
               </a:spcBef>
-              <a:defRPr sz="1300">
+              <a:defRPr sz="1600" b="1">
                 <a:solidFill>
                   <a:srgbClr val="FFFFFF"/>
                 </a:solidFill>
+                <a:latin typeface="Poppins"/>
+              </a:defRPr>
+            </a:pPr>
+            <a:r>
+              <a:t>Cost Reduction</a:t>
+            </a:r>
+          </a:p>
+          <a:p>
+            <a:pPr>
+              <a:spcBef>
+                <a:spcPts val="1400"/>
+              </a:spcBef>
+              <a:defRPr sz="1100">
+                <a:solidFill>
+                  <a:srgbClr val="B2DFDB"/>
+                </a:solidFill>
                 <a:latin typeface="Inter"/>
               </a:defRPr>
             </a:pPr>
             <a:r>
-              <a:t>ESP32 Microcontrollers, Ultrasonic Waste Sensors, Flow Telemetry</a:t>
+              <a:t>Lower Facilities Maintenance Costs</a:t>
             </a:r>
           </a:p>
         </p:txBody>
@@ -6688,8 +6129,8 @@
         </p:nvSpPr>
         <p:spPr>
           <a:xfrm>
-            <a:off x="731520" y="365760"/>
-            <a:ext cx="10728655" cy="914400"/>
+            <a:off x="731520" y="274320"/>
+            <a:ext cx="10728655" cy="822960"/>
           </a:xfrm>
           <a:prstGeom prst="rect">
             <a:avLst/>
@@ -6703,7 +6144,7 @@
           <a:lstStyle/>
           <a:p>
             <a:pPr>
-              <a:defRPr sz="2800" b="1">
+              <a:defRPr sz="2600" b="1">
                 <a:solidFill>
                   <a:srgbClr val="FFFFFF"/>
                 </a:solidFill>
@@ -6711,15 +6152,15 @@
               </a:defRPr>
             </a:pPr>
             <a:r>
-              <a:t>10 CORE PLATFORM FEATURES</a:t>
+              <a:t>Slide 7  |  Scaling Strategy &amp; Future Roadmap</a:t>
             </a:r>
           </a:p>
           <a:p>
             <a:pPr>
               <a:spcBef>
-                <a:spcPts val="400"/>
+                <a:spcPts val="300"/>
               </a:spcBef>
-              <a:defRPr sz="1300">
+              <a:defRPr sz="1200">
                 <a:solidFill>
                   <a:srgbClr val="00E5FF"/>
                 </a:solidFill>
@@ -6727,7 +6168,7 @@
               </a:defRPr>
             </a:pPr>
             <a:r>
-              <a:t>Integrated Modules Powering Smart Campus Operations</a:t>
+              <a:t>From SPNREC Pilot to a National Smart Campus Network</a:t>
             </a:r>
           </a:p>
         </p:txBody>
@@ -6740,8 +6181,8 @@
         </p:nvSpPr>
         <p:spPr>
           <a:xfrm>
-            <a:off x="731520" y="1645920"/>
-            <a:ext cx="2011680" cy="2011680"/>
+            <a:off x="731520" y="1463040"/>
+            <a:ext cx="2011680" cy="2286000"/>
           </a:xfrm>
           <a:prstGeom prst="roundRect">
             <a:avLst/>
@@ -6774,7 +6215,7 @@
           <a:lstStyle/>
           <a:p>
             <a:pPr algn="ctr">
-              <a:defRPr sz="1300" b="1">
+              <a:defRPr sz="1200" b="1">
                 <a:solidFill>
                   <a:srgbClr val="00FF66"/>
                 </a:solidFill>
@@ -6782,22 +6223,23 @@
               </a:defRPr>
             </a:pPr>
             <a:r>
-              <a:t>1. Smart Waste Monitoring</a:t>
+              <a:t>1. SPNREC Pilot</a:t>
             </a:r>
           </a:p>
           <a:p>
             <a:pPr>
               <a:spcBef>
-                <a:spcPts val="800"/>
+                <a:spcPts val="600"/>
               </a:spcBef>
               <a:defRPr sz="1000">
                 <a:solidFill>
                   <a:srgbClr val="B2DFDB"/>
                 </a:solidFill>
-              </a:defRPr>
-            </a:pPr>
-            <a:r>
-              <a:t>Operational &amp; Active</a:t>
+                <a:latin typeface="Inter"/>
+              </a:defRPr>
+            </a:pPr>
+            <a:r>
+              <a:t>Deploy &amp; validate solutions across Araria campus.</a:t>
             </a:r>
           </a:p>
         </p:txBody>
@@ -6810,8 +6252,8 @@
         </p:nvSpPr>
         <p:spPr>
           <a:xfrm>
-            <a:off x="2907791" y="1645920"/>
-            <a:ext cx="2011680" cy="2011680"/>
+            <a:off x="2907791" y="1463040"/>
+            <a:ext cx="2011680" cy="2286000"/>
           </a:xfrm>
           <a:prstGeom prst="roundRect">
             <a:avLst/>
@@ -6844,7 +6286,7 @@
           <a:lstStyle/>
           <a:p>
             <a:pPr algn="ctr">
-              <a:defRPr sz="1300" b="1">
+              <a:defRPr sz="1200" b="1">
                 <a:solidFill>
                   <a:srgbClr val="00FF66"/>
                 </a:solidFill>
@@ -6852,22 +6294,23 @@
               </a:defRPr>
             </a:pPr>
             <a:r>
-              <a:t>2. Smart Water Monitoring</a:t>
+              <a:t>2. District Colleges</a:t>
             </a:r>
           </a:p>
           <a:p>
             <a:pPr>
               <a:spcBef>
-                <a:spcPts val="800"/>
+                <a:spcPts val="600"/>
               </a:spcBef>
               <a:defRPr sz="1000">
                 <a:solidFill>
                   <a:srgbClr val="B2DFDB"/>
                 </a:solidFill>
-              </a:defRPr>
-            </a:pPr>
-            <a:r>
-              <a:t>Operational &amp; Active</a:t>
+                <a:latin typeface="Inter"/>
+              </a:defRPr>
+            </a:pPr>
+            <a:r>
+              <a:t>Expand to nearby Bihar district colleges.</a:t>
             </a:r>
           </a:p>
         </p:txBody>
@@ -6880,8 +6323,8 @@
         </p:nvSpPr>
         <p:spPr>
           <a:xfrm>
-            <a:off x="5084064" y="1645920"/>
-            <a:ext cx="2011680" cy="2011680"/>
+            <a:off x="5084064" y="1463040"/>
+            <a:ext cx="2011680" cy="2286000"/>
           </a:xfrm>
           <a:prstGeom prst="roundRect">
             <a:avLst/>
@@ -6914,7 +6357,7 @@
           <a:lstStyle/>
           <a:p>
             <a:pPr algn="ctr">
-              <a:defRPr sz="1300" b="1">
+              <a:defRPr sz="1200" b="1">
                 <a:solidFill>
                   <a:srgbClr val="00FF66"/>
                 </a:solidFill>
@@ -6922,22 +6365,23 @@
               </a:defRPr>
             </a:pPr>
             <a:r>
-              <a:t>3. Solar Grid Telemetry</a:t>
+              <a:t>3. Engineering Colleges</a:t>
             </a:r>
           </a:p>
           <a:p>
             <a:pPr>
               <a:spcBef>
-                <a:spcPts val="800"/>
+                <a:spcPts val="600"/>
               </a:spcBef>
               <a:defRPr sz="1000">
                 <a:solidFill>
                   <a:srgbClr val="B2DFDB"/>
                 </a:solidFill>
-              </a:defRPr>
-            </a:pPr>
-            <a:r>
-              <a:t>Operational &amp; Active</a:t>
+                <a:latin typeface="Inter"/>
+              </a:defRPr>
+            </a:pPr>
+            <a:r>
+              <a:t>Scale to all state engineering institutes.</a:t>
             </a:r>
           </a:p>
         </p:txBody>
@@ -6950,8 +6394,8 @@
         </p:nvSpPr>
         <p:spPr>
           <a:xfrm>
-            <a:off x="7260336" y="1645920"/>
-            <a:ext cx="2011680" cy="2011680"/>
+            <a:off x="7260336" y="1463040"/>
+            <a:ext cx="2011680" cy="2286000"/>
           </a:xfrm>
           <a:prstGeom prst="roundRect">
             <a:avLst/>
@@ -6984,7 +6428,7 @@
           <a:lstStyle/>
           <a:p>
             <a:pPr algn="ctr">
-              <a:defRPr sz="1300" b="1">
+              <a:defRPr sz="1200" b="1">
                 <a:solidFill>
                   <a:srgbClr val="00FF66"/>
                 </a:solidFill>
@@ -6992,22 +6436,23 @@
               </a:defRPr>
             </a:pPr>
             <a:r>
-              <a:t>4. GIS Campus Radar Map</a:t>
+              <a:t>4. Universities</a:t>
             </a:r>
           </a:p>
           <a:p>
             <a:pPr>
               <a:spcBef>
-                <a:spcPts val="800"/>
+                <a:spcPts val="600"/>
               </a:spcBef>
               <a:defRPr sz="1000">
                 <a:solidFill>
                   <a:srgbClr val="B2DFDB"/>
                 </a:solidFill>
-              </a:defRPr>
-            </a:pPr>
-            <a:r>
-              <a:t>Operational &amp; Active</a:t>
+                <a:latin typeface="Inter"/>
+              </a:defRPr>
+            </a:pPr>
+            <a:r>
+              <a:t>University-wide deployment &amp; policy integration.</a:t>
             </a:r>
           </a:p>
         </p:txBody>
@@ -7020,8 +6465,8 @@
         </p:nvSpPr>
         <p:spPr>
           <a:xfrm>
-            <a:off x="9436608" y="1645920"/>
-            <a:ext cx="2011680" cy="2011680"/>
+            <a:off x="9436608" y="1463040"/>
+            <a:ext cx="2011680" cy="2286000"/>
           </a:xfrm>
           <a:prstGeom prst="roundRect">
             <a:avLst/>
@@ -7054,7 +6499,7 @@
           <a:lstStyle/>
           <a:p>
             <a:pPr algn="ctr">
-              <a:defRPr sz="1300" b="1">
+              <a:defRPr sz="1200" b="1">
                 <a:solidFill>
                   <a:srgbClr val="00FF66"/>
                 </a:solidFill>
@@ -7062,22 +6507,23 @@
               </a:defRPr>
             </a:pPr>
             <a:r>
-              <a:t>5. GreenBot AI Copilot</a:t>
+              <a:t>5. National Network</a:t>
             </a:r>
           </a:p>
           <a:p>
             <a:pPr>
               <a:spcBef>
-                <a:spcPts val="800"/>
+                <a:spcPts val="600"/>
               </a:spcBef>
               <a:defRPr sz="1000">
                 <a:solidFill>
                   <a:srgbClr val="B2DFDB"/>
                 </a:solidFill>
-              </a:defRPr>
-            </a:pPr>
-            <a:r>
-              <a:t>Operational &amp; Active</a:t>
+                <a:latin typeface="Inter"/>
+              </a:defRPr>
+            </a:pPr>
+            <a:r>
+              <a:t>Pan-India data-driven national campus network.</a:t>
             </a:r>
           </a:p>
         </p:txBody>
@@ -7090,8 +6536,8 @@
         </p:nvSpPr>
         <p:spPr>
           <a:xfrm>
-            <a:off x="731520" y="4023360"/>
-            <a:ext cx="2011680" cy="2011680"/>
+            <a:off x="731520" y="3931920"/>
+            <a:ext cx="5212080" cy="2286000"/>
           </a:xfrm>
           <a:prstGeom prst="roundRect">
             <a:avLst/>
@@ -7120,34 +6566,49 @@
           </a:fontRef>
         </p:style>
         <p:txBody>
-          <a:bodyPr rtlCol="0" anchor="ctr" wrap="square" lIns="137160" tIns="137160"/>
+          <a:bodyPr rtlCol="0" anchor="ctr" wrap="square" lIns="182880" tIns="182880"/>
           <a:lstStyle/>
           <a:p>
             <a:pPr algn="ctr">
-              <a:defRPr sz="1300" b="1">
-                <a:solidFill>
-                  <a:srgbClr val="00FF66"/>
-                </a:solidFill>
-                <a:latin typeface="Poppins"/>
-              </a:defRPr>
-            </a:pPr>
-            <a:r>
-              <a:t>6. AI Vision Defect Scanner</a:t>
+              <a:defRPr sz="1400" b="1">
+                <a:solidFill>
+                  <a:srgbClr val="00E5FF"/>
+                </a:solidFill>
+              </a:defRPr>
+            </a:pPr>
+            <a:r>
+              <a:t>🤝 STRATEGIC PARTNERS &amp; ECOSYSTEM</a:t>
             </a:r>
           </a:p>
           <a:p>
             <a:pPr>
               <a:spcBef>
-                <a:spcPts val="800"/>
+                <a:spcPts val="600"/>
               </a:spcBef>
-              <a:defRPr sz="1000">
-                <a:solidFill>
-                  <a:srgbClr val="B2DFDB"/>
-                </a:solidFill>
-              </a:defRPr>
-            </a:pPr>
-            <a:r>
-              <a:t>Operational &amp; Active</a:t>
+              <a:defRPr sz="1100">
+                <a:solidFill>
+                  <a:srgbClr val="FFFFFF"/>
+                </a:solidFill>
+              </a:defRPr>
+            </a:pPr>
+            <a:r>
+              <a:t>• Microsoft (Cloud &amp; AI Integration)</a:t>
+            </a:r>
+            <a:br/>
+            <a:r>
+              <a:t>• Supabase (Database Infrastructure)</a:t>
+            </a:r>
+            <a:br/>
+            <a:r>
+              <a:t>• Google Gemini AI &amp; Leaflet GIS</a:t>
+            </a:r>
+            <a:br/>
+            <a:r>
+              <a:t>• MeitY &amp; ISRO (Geospatial Data)</a:t>
+            </a:r>
+            <a:br/>
+            <a:r>
+              <a:t>• Academic Institutions &amp; Environmental NGOs</a:t>
             </a:r>
           </a:p>
         </p:txBody>
@@ -7160,8 +6621,8 @@
         </p:nvSpPr>
         <p:spPr>
           <a:xfrm>
-            <a:off x="2907791" y="4023360"/>
-            <a:ext cx="2011680" cy="2011680"/>
+            <a:off x="6217920" y="3931920"/>
+            <a:ext cx="5212080" cy="2286000"/>
           </a:xfrm>
           <a:prstGeom prst="roundRect">
             <a:avLst/>
@@ -7190,244 +6651,41 @@
           </a:fontRef>
         </p:style>
         <p:txBody>
-          <a:bodyPr rtlCol="0" anchor="ctr" wrap="square" lIns="137160" tIns="137160"/>
+          <a:bodyPr rtlCol="0" anchor="ctr" wrap="square" lIns="182880" tIns="182880"/>
           <a:lstStyle/>
           <a:p>
             <a:pPr algn="ctr">
-              <a:defRPr sz="1300" b="1">
+              <a:defRPr sz="1400" b="1">
                 <a:solidFill>
                   <a:srgbClr val="00FF66"/>
                 </a:solidFill>
-                <a:latin typeface="Poppins"/>
-              </a:defRPr>
-            </a:pPr>
-            <a:r>
-              <a:t>7. IoT Hardware Mesh</a:t>
+              </a:defRPr>
+            </a:pPr>
+            <a:r>
+              <a:t>🚀 FUTURE EXPANSION MODULES</a:t>
             </a:r>
           </a:p>
           <a:p>
             <a:pPr>
               <a:spcBef>
-                <a:spcPts val="800"/>
+                <a:spcPts val="600"/>
               </a:spcBef>
-              <a:defRPr sz="1000">
-                <a:solidFill>
-                  <a:srgbClr val="B2DFDB"/>
-                </a:solidFill>
-              </a:defRPr>
-            </a:pPr>
-            <a:r>
-              <a:t>Operational &amp; Active</a:t>
-            </a:r>
-          </a:p>
-        </p:txBody>
-      </p:sp>
-      <p:sp>
-        <p:nvSpPr>
-          <p:cNvPr id="10" name="Rounded Rectangle 9"/>
-          <p:cNvSpPr/>
-          <p:nvPr/>
-        </p:nvSpPr>
-        <p:spPr>
-          <a:xfrm>
-            <a:off x="5084064" y="4023360"/>
-            <a:ext cx="2011680" cy="2011680"/>
-          </a:xfrm>
-          <a:prstGeom prst="roundRect">
-            <a:avLst/>
-          </a:prstGeom>
-          <a:solidFill>
-            <a:srgbClr val="0E2A1F"/>
-          </a:solidFill>
-          <a:ln w="19050">
-            <a:solidFill>
-              <a:srgbClr val="00C853"/>
-            </a:solidFill>
-          </a:ln>
-        </p:spPr>
-        <p:style>
-          <a:lnRef idx="1">
-            <a:schemeClr val="accent1"/>
-          </a:lnRef>
-          <a:fillRef idx="3">
-            <a:schemeClr val="accent1"/>
-          </a:fillRef>
-          <a:effectRef idx="2">
-            <a:schemeClr val="accent1"/>
-          </a:effectRef>
-          <a:fontRef idx="minor">
-            <a:schemeClr val="lt1"/>
-          </a:fontRef>
-        </p:style>
-        <p:txBody>
-          <a:bodyPr rtlCol="0" anchor="ctr" wrap="square" lIns="137160" tIns="137160"/>
-          <a:lstStyle/>
-          <a:p>
-            <a:pPr algn="ctr">
-              <a:defRPr sz="1300" b="1">
-                <a:solidFill>
-                  <a:srgbClr val="00FF66"/>
-                </a:solidFill>
-                <a:latin typeface="Poppins"/>
-              </a:defRPr>
-            </a:pPr>
-            <a:r>
-              <a:t>8. Executive Sustainability HUD</a:t>
-            </a:r>
-          </a:p>
-          <a:p>
-            <a:pPr>
-              <a:spcBef>
-                <a:spcPts val="800"/>
-              </a:spcBef>
-              <a:defRPr sz="1000">
-                <a:solidFill>
-                  <a:srgbClr val="B2DFDB"/>
-                </a:solidFill>
-              </a:defRPr>
-            </a:pPr>
-            <a:r>
-              <a:t>Operational &amp; Active</a:t>
-            </a:r>
-          </a:p>
-        </p:txBody>
-      </p:sp>
-      <p:sp>
-        <p:nvSpPr>
-          <p:cNvPr id="11" name="Rounded Rectangle 10"/>
-          <p:cNvSpPr/>
-          <p:nvPr/>
-        </p:nvSpPr>
-        <p:spPr>
-          <a:xfrm>
-            <a:off x="7260336" y="4023360"/>
-            <a:ext cx="2011680" cy="2011680"/>
-          </a:xfrm>
-          <a:prstGeom prst="roundRect">
-            <a:avLst/>
-          </a:prstGeom>
-          <a:solidFill>
-            <a:srgbClr val="0E2A1F"/>
-          </a:solidFill>
-          <a:ln w="19050">
-            <a:solidFill>
-              <a:srgbClr val="00C853"/>
-            </a:solidFill>
-          </a:ln>
-        </p:spPr>
-        <p:style>
-          <a:lnRef idx="1">
-            <a:schemeClr val="accent1"/>
-          </a:lnRef>
-          <a:fillRef idx="3">
-            <a:schemeClr val="accent1"/>
-          </a:fillRef>
-          <a:effectRef idx="2">
-            <a:schemeClr val="accent1"/>
-          </a:effectRef>
-          <a:fontRef idx="minor">
-            <a:schemeClr val="lt1"/>
-          </a:fontRef>
-        </p:style>
-        <p:txBody>
-          <a:bodyPr rtlCol="0" anchor="ctr" wrap="square" lIns="137160" tIns="137160"/>
-          <a:lstStyle/>
-          <a:p>
-            <a:pPr algn="ctr">
-              <a:defRPr sz="1300" b="1">
-                <a:solidFill>
-                  <a:srgbClr val="00FF66"/>
-                </a:solidFill>
-                <a:latin typeface="Poppins"/>
-              </a:defRPr>
-            </a:pPr>
-            <a:r>
-              <a:t>9. Green Rewards Leaderboard</a:t>
-            </a:r>
-          </a:p>
-          <a:p>
-            <a:pPr>
-              <a:spcBef>
-                <a:spcPts val="800"/>
-              </a:spcBef>
-              <a:defRPr sz="1000">
-                <a:solidFill>
-                  <a:srgbClr val="B2DFDB"/>
-                </a:solidFill>
-              </a:defRPr>
-            </a:pPr>
-            <a:r>
-              <a:t>Operational &amp; Active</a:t>
-            </a:r>
-          </a:p>
-        </p:txBody>
-      </p:sp>
-      <p:sp>
-        <p:nvSpPr>
-          <p:cNvPr id="12" name="Rounded Rectangle 11"/>
-          <p:cNvSpPr/>
-          <p:nvPr/>
-        </p:nvSpPr>
-        <p:spPr>
-          <a:xfrm>
-            <a:off x="9436608" y="4023360"/>
-            <a:ext cx="2011680" cy="2011680"/>
-          </a:xfrm>
-          <a:prstGeom prst="roundRect">
-            <a:avLst/>
-          </a:prstGeom>
-          <a:solidFill>
-            <a:srgbClr val="0E2A1F"/>
-          </a:solidFill>
-          <a:ln w="19050">
-            <a:solidFill>
-              <a:srgbClr val="00C853"/>
-            </a:solidFill>
-          </a:ln>
-        </p:spPr>
-        <p:style>
-          <a:lnRef idx="1">
-            <a:schemeClr val="accent1"/>
-          </a:lnRef>
-          <a:fillRef idx="3">
-            <a:schemeClr val="accent1"/>
-          </a:fillRef>
-          <a:effectRef idx="2">
-            <a:schemeClr val="accent1"/>
-          </a:effectRef>
-          <a:fontRef idx="minor">
-            <a:schemeClr val="lt1"/>
-          </a:fontRef>
-        </p:style>
-        <p:txBody>
-          <a:bodyPr rtlCol="0" anchor="ctr" wrap="square" lIns="137160" tIns="137160"/>
-          <a:lstStyle/>
-          <a:p>
-            <a:pPr algn="ctr">
-              <a:defRPr sz="1300" b="1">
-                <a:solidFill>
-                  <a:srgbClr val="00FF66"/>
-                </a:solidFill>
-                <a:latin typeface="Poppins"/>
-              </a:defRPr>
-            </a:pPr>
-            <a:r>
-              <a:t>10. Cloud Edge Database Sync</a:t>
-            </a:r>
-          </a:p>
-          <a:p>
-            <a:pPr>
-              <a:spcBef>
-                <a:spcPts val="800"/>
-              </a:spcBef>
-              <a:defRPr sz="1000">
-                <a:solidFill>
-                  <a:srgbClr val="B2DFDB"/>
-                </a:solidFill>
-              </a:defRPr>
-            </a:pPr>
-            <a:r>
-              <a:t>Operational &amp; Active</a:t>
+              <a:defRPr sz="1100">
+                <a:solidFill>
+                  <a:srgbClr val="FFFFFF"/>
+                </a:solidFill>
+              </a:defRPr>
+            </a:pPr>
+            <a:r>
+              <a:t>• Smart Parking: Real-time IoT slot tracking to reduce vehicle emissions.</a:t>
+            </a:r>
+            <a:br/>
+            <a:r>
+              <a:t>• Carbon Tracking: Live emissions dashboard &amp; Net-Zero targets.</a:t>
+            </a:r>
+            <a:br/>
+            <a:r>
+              <a:t>• Digital Twin Campus: 3D virtual replica for predictive maintenance simulation.</a:t>
             </a:r>
           </a:p>
         </p:txBody>
@@ -7466,8 +6724,8 @@
         </p:nvSpPr>
         <p:spPr>
           <a:xfrm>
-            <a:off x="731520" y="365760"/>
-            <a:ext cx="10728655" cy="914400"/>
+            <a:off x="731520" y="274320"/>
+            <a:ext cx="10728655" cy="822960"/>
           </a:xfrm>
           <a:prstGeom prst="rect">
             <a:avLst/>
@@ -7481,7 +6739,7 @@
           <a:lstStyle/>
           <a:p>
             <a:pPr>
-              <a:defRPr sz="2800" b="1">
+              <a:defRPr sz="2600" b="1">
                 <a:solidFill>
                   <a:srgbClr val="FFFFFF"/>
                 </a:solidFill>
@@ -7489,15 +6747,15 @@
               </a:defRPr>
             </a:pPr>
             <a:r>
-              <a:t>ADMIN SECURITY CONTROL CENTER</a:t>
+              <a:t>Slide 8  |  Risks, AI Tools &amp; Conclusion</a:t>
             </a:r>
           </a:p>
           <a:p>
             <a:pPr>
               <a:spcBef>
-                <a:spcPts val="400"/>
+                <a:spcPts val="300"/>
               </a:spcBef>
-              <a:defRPr sz="1300">
+              <a:defRPr sz="1200">
                 <a:solidFill>
                   <a:srgbClr val="00E5FF"/>
                 </a:solidFill>
@@ -7505,7 +6763,7 @@
               </a:defRPr>
             </a:pPr>
             <a:r>
-              <a:t>Role-Based Access Control &amp; Real-Time Incident Management</a:t>
+              <a:t>Mitigation Governance, Key Learnings, and Project Accreditation</a:t>
             </a:r>
           </a:p>
         </p:txBody>
@@ -7518,8 +6776,8 @@
         </p:nvSpPr>
         <p:spPr>
           <a:xfrm>
-            <a:off x="731520" y="1645920"/>
-            <a:ext cx="7040880" cy="4389120"/>
+            <a:off x="731520" y="1463040"/>
+            <a:ext cx="5212080" cy="4754880"/>
           </a:xfrm>
           <a:prstGeom prst="roundRect">
             <a:avLst/>
@@ -7548,45 +6806,49 @@
           </a:fontRef>
         </p:style>
         <p:txBody>
-          <a:bodyPr rtlCol="0" anchor="ctr" wrap="square" lIns="274320" tIns="274320"/>
+          <a:bodyPr rtlCol="0" anchor="ctr" wrap="square" lIns="182880" tIns="182880"/>
           <a:lstStyle/>
           <a:p>
             <a:pPr algn="ctr">
-              <a:defRPr sz="1800" b="1">
+              <a:defRPr sz="1500" b="1">
                 <a:solidFill>
                   <a:srgbClr val="00FF66"/>
                 </a:solidFill>
               </a:defRPr>
             </a:pPr>
             <a:r>
-              <a:t>🛡️ Centralized Governance &amp; Facilities Oversight</a:t>
+              <a:t>🛡️ RISKS &amp; MITIGATION</a:t>
             </a:r>
           </a:p>
           <a:p>
             <a:pPr>
               <a:spcBef>
-                <a:spcPts val="1400"/>
+                <a:spcPts val="800"/>
               </a:spcBef>
-              <a:defRPr sz="1300">
+              <a:defRPr sz="1100">
                 <a:solidFill>
                   <a:srgbClr val="FFFFFF"/>
                 </a:solidFill>
               </a:defRPr>
             </a:pPr>
             <a:r>
-              <a:t>• Role-Based Access Control (RBAC): Isolated portals for Students, Maintenance Staff, and Administrators.</a:t>
+              <a:t>• Data Privacy: End-to-end encryption &amp; RLS isolation.</a:t>
             </a:r>
             <a:br/>
             <a:r>
-              <a:t>• Real-Time Verification Pipeline: Technicians submit completion photos verified by admins before ticket resolution.</a:t>
+              <a:t>• Hardware Failure: Automated alerts &amp; regular telemetry checks.</a:t>
             </a:r>
             <a:br/>
             <a:r>
-              <a:t>• IoT Sensor Override &amp; Diagnostic Stream: Live control of ESP32 sensor threshold warnings.</a:t>
+              <a:t>• Data Inaccuracy: Multi-source verification algorithms.</a:t>
             </a:r>
             <a:br/>
             <a:r>
-              <a:t>• User Directory &amp; Leaderboard Controls: Audit student points, badge allocations, and campus rankings.</a:t>
+              <a:t>• User Engagement: Gamified Eco-Points &amp; Leaderboards.</a:t>
+            </a:r>
+            <a:br/>
+            <a:r>
+              <a:t>• System Uptime: Scalable Vercel &amp; Supabase Cloud hosting.</a:t>
             </a:r>
           </a:p>
         </p:txBody>
@@ -7599,8 +6861,8 @@
         </p:nvSpPr>
         <p:spPr>
           <a:xfrm>
-            <a:off x="8046720" y="1645920"/>
-            <a:ext cx="3383280" cy="4389120"/>
+            <a:off x="6217920" y="1463040"/>
+            <a:ext cx="5212080" cy="2011680"/>
           </a:xfrm>
           <a:prstGeom prst="roundRect">
             <a:avLst/>
@@ -7610,7 +6872,7 @@
           </a:solidFill>
           <a:ln w="19050">
             <a:solidFill>
-              <a:srgbClr val="00E5FF"/>
+              <a:srgbClr val="00C853"/>
             </a:solidFill>
           </a:ln>
         </p:spPr>
@@ -7629,125 +6891,55 @@
           </a:fontRef>
         </p:style>
         <p:txBody>
-          <a:bodyPr rtlCol="0" anchor="ctr"/>
-          <a:lstStyle/>
-          <a:p>
-            <a:pPr algn="ctr"/>
-          </a:p>
-        </p:txBody>
-      </p:sp>
-      <p:pic>
-        <p:nvPicPr>
-          <p:cNvPr id="5" name="Picture 4" descr="3d_ai_brain.jpg"/>
-          <p:cNvPicPr>
-            <a:picLocks noChangeAspect="1"/>
-          </p:cNvPicPr>
-          <p:nvPr/>
-        </p:nvPicPr>
-        <p:blipFill>
-          <a:blip r:embed="rId2"/>
-          <a:stretch>
-            <a:fillRect/>
-          </a:stretch>
-        </p:blipFill>
-        <p:spPr>
-          <a:xfrm>
-            <a:off x="8138160" y="1737360"/>
-            <a:ext cx="3200400" cy="4206240"/>
-          </a:xfrm>
-          <a:prstGeom prst="rect">
-            <a:avLst/>
-          </a:prstGeom>
-        </p:spPr>
-      </p:pic>
-    </p:spTree>
-  </p:cSld>
-  <p:clrMapOvr>
-    <a:masterClrMapping/>
-  </p:clrMapOvr>
-</p:sld>
-</file>
-
-<file path=ppt/slides/slide9.xml><?xml version="1.0" encoding="utf-8"?>
-<p:sld xmlns:a="http://schemas.openxmlformats.org/drawingml/2006/main" xmlns:p="http://schemas.openxmlformats.org/presentationml/2006/main" xmlns:r="http://schemas.openxmlformats.org/officeDocument/2006/relationships">
-  <p:cSld>
-    <p:bg>
-      <p:bgPr>
-        <a:solidFill>
-          <a:srgbClr val="071A12"/>
-        </a:solidFill>
-        <a:effectLst/>
-      </p:bgPr>
-    </p:bg>
-    <p:spTree>
-      <p:nvGrpSpPr>
-        <p:cNvPr id="1" name=""/>
-        <p:cNvGrpSpPr/>
-        <p:nvPr/>
-      </p:nvGrpSpPr>
-      <p:grpSpPr/>
-      <p:sp>
-        <p:nvSpPr>
-          <p:cNvPr id="2" name="TextBox 1"/>
-          <p:cNvSpPr txBox="1"/>
-          <p:nvPr/>
-        </p:nvSpPr>
-        <p:spPr>
-          <a:xfrm>
-            <a:off x="731520" y="365760"/>
-            <a:ext cx="10728655" cy="914400"/>
-          </a:xfrm>
-          <a:prstGeom prst="rect">
-            <a:avLst/>
-          </a:prstGeom>
-          <a:noFill/>
-        </p:spPr>
-        <p:txBody>
-          <a:bodyPr wrap="square" lIns="0" tIns="0" rIns="0" bIns="0">
-            <a:spAutoFit/>
-          </a:bodyPr>
-          <a:lstStyle/>
-          <a:p>
-            <a:pPr>
-              <a:defRPr sz="2800" b="1">
-                <a:solidFill>
-                  <a:srgbClr val="FFFFFF"/>
-                </a:solidFill>
-                <a:latin typeface="Poppins"/>
-              </a:defRPr>
-            </a:pPr>
-            <a:r>
-              <a:t>MEASURED RESULTS &amp; SUSTAINABILITY KPIS</a:t>
+          <a:bodyPr rtlCol="0" anchor="ctr" wrap="square" lIns="182880" tIns="182880"/>
+          <a:lstStyle/>
+          <a:p>
+            <a:pPr algn="ctr">
+              <a:defRPr sz="1500" b="1">
+                <a:solidFill>
+                  <a:srgbClr val="00E5FF"/>
+                </a:solidFill>
+              </a:defRPr>
+            </a:pPr>
+            <a:r>
+              <a:t>📖 KEY LEARNINGS</a:t>
             </a:r>
           </a:p>
           <a:p>
             <a:pPr>
               <a:spcBef>
-                <a:spcPts val="400"/>
+                <a:spcPts val="600"/>
               </a:spcBef>
-              <a:defRPr sz="1300">
-                <a:solidFill>
-                  <a:srgbClr val="00E5FF"/>
-                </a:solidFill>
-                <a:latin typeface="Inter"/>
-              </a:defRPr>
-            </a:pPr>
-            <a:r>
-              <a:t>Quantifiable Environmental Impact Across SPNREC Campus</a:t>
-            </a:r>
-          </a:p>
-        </p:txBody>
-      </p:sp>
-      <p:sp>
-        <p:nvSpPr>
-          <p:cNvPr id="3" name="Rounded Rectangle 2"/>
+              <a:defRPr sz="1100">
+                <a:solidFill>
+                  <a:srgbClr val="FFFFFF"/>
+                </a:solidFill>
+              </a:defRPr>
+            </a:pPr>
+            <a:r>
+              <a:t>• Integrated AI, IoT, GIS &amp; Cloud for real-world impact.</a:t>
+            </a:r>
+            <a:br/>
+            <a:r>
+              <a:t>• Hands-on full-stack engineering &amp; state management.</a:t>
+            </a:r>
+            <a:br/>
+            <a:r>
+              <a:t>• Data-driven decision making for smart campus management.</a:t>
+            </a:r>
+          </a:p>
+        </p:txBody>
+      </p:sp>
+      <p:sp>
+        <p:nvSpPr>
+          <p:cNvPr id="5" name="Rounded Rectangle 4"/>
           <p:cNvSpPr/>
           <p:nvPr/>
         </p:nvSpPr>
         <p:spPr>
           <a:xfrm>
-            <a:off x="731520" y="1645920"/>
-            <a:ext cx="2468880" cy="4389120"/>
+            <a:off x="6217920" y="3657600"/>
+            <a:ext cx="5212080" cy="2560320"/>
           </a:xfrm>
           <a:prstGeom prst="roundRect">
             <a:avLst/>
@@ -7780,308 +6972,52 @@
           <a:lstStyle/>
           <a:p>
             <a:pPr algn="ctr">
-              <a:defRPr sz="4000" b="1">
+              <a:defRPr sz="1800" b="1">
                 <a:solidFill>
                   <a:srgbClr val="00FF66"/>
                 </a:solidFill>
-                <a:latin typeface="Montserrat"/>
-              </a:defRPr>
-            </a:pPr>
-            <a:r>
-              <a:t>40%</a:t>
+              </a:defRPr>
+            </a:pPr>
+            <a:r>
+              <a:t>✨ THANK YOU!</a:t>
             </a:r>
           </a:p>
           <a:p>
             <a:pPr>
               <a:spcBef>
-                <a:spcPts val="1000"/>
+                <a:spcPts val="400"/>
               </a:spcBef>
-              <a:defRPr sz="1600" b="1">
+              <a:defRPr sz="1100" b="1">
                 <a:solidFill>
                   <a:srgbClr val="FFFFFF"/>
                 </a:solidFill>
-                <a:latin typeface="Poppins"/>
-              </a:defRPr>
-            </a:pPr>
-            <a:r>
-              <a:t>Water Saving</a:t>
+              </a:defRPr>
+            </a:pPr>
+            <a:r>
+              <a:t>Together, let's build smarter, greener &amp; sustainable campuses.</a:t>
             </a:r>
           </a:p>
           <a:p>
             <a:pPr>
               <a:spcBef>
-                <a:spcPts val="1400"/>
+                <a:spcPts val="600"/>
               </a:spcBef>
-              <a:defRPr sz="1100">
+              <a:defRPr sz="1000">
                 <a:solidFill>
                   <a:srgbClr val="B2DFDB"/>
                 </a:solidFill>
-                <a:latin typeface="Inter"/>
-              </a:defRPr>
-            </a:pPr>
-            <a:r>
-              <a:t>Recycled Greywater &amp; Leak Repairs</a:t>
-            </a:r>
-          </a:p>
-        </p:txBody>
-      </p:sp>
-      <p:sp>
-        <p:nvSpPr>
-          <p:cNvPr id="4" name="Rounded Rectangle 3"/>
-          <p:cNvSpPr/>
-          <p:nvPr/>
-        </p:nvSpPr>
-        <p:spPr>
-          <a:xfrm>
-            <a:off x="3429000" y="1645920"/>
-            <a:ext cx="2468880" cy="4389120"/>
-          </a:xfrm>
-          <a:prstGeom prst="roundRect">
-            <a:avLst/>
-          </a:prstGeom>
-          <a:solidFill>
-            <a:srgbClr val="0E2A1F"/>
-          </a:solidFill>
-          <a:ln w="19050">
-            <a:solidFill>
-              <a:srgbClr val="00FF66"/>
-            </a:solidFill>
-          </a:ln>
-        </p:spPr>
-        <p:style>
-          <a:lnRef idx="1">
-            <a:schemeClr val="accent1"/>
-          </a:lnRef>
-          <a:fillRef idx="3">
-            <a:schemeClr val="accent1"/>
-          </a:fillRef>
-          <a:effectRef idx="2">
-            <a:schemeClr val="accent1"/>
-          </a:effectRef>
-          <a:fontRef idx="minor">
-            <a:schemeClr val="lt1"/>
-          </a:fontRef>
-        </p:style>
-        <p:txBody>
-          <a:bodyPr rtlCol="0" anchor="ctr" wrap="square" lIns="182880" tIns="182880"/>
-          <a:lstStyle/>
-          <a:p>
-            <a:pPr algn="ctr">
-              <a:defRPr sz="4000" b="1">
-                <a:solidFill>
-                  <a:srgbClr val="00FF66"/>
-                </a:solidFill>
-                <a:latin typeface="Montserrat"/>
-              </a:defRPr>
-            </a:pPr>
-            <a:r>
-              <a:t>35%</a:t>
-            </a:r>
-          </a:p>
-          <a:p>
-            <a:pPr>
-              <a:spcBef>
-                <a:spcPts val="1000"/>
-              </a:spcBef>
-              <a:defRPr sz="1600" b="1">
-                <a:solidFill>
-                  <a:srgbClr val="FFFFFF"/>
-                </a:solidFill>
-                <a:latin typeface="Poppins"/>
-              </a:defRPr>
-            </a:pPr>
-            <a:r>
-              <a:t>Energy Saving</a:t>
-            </a:r>
-          </a:p>
-          <a:p>
-            <a:pPr>
-              <a:spcBef>
-                <a:spcPts val="1400"/>
-              </a:spcBef>
-              <a:defRPr sz="1100">
-                <a:solidFill>
-                  <a:srgbClr val="B2DFDB"/>
-                </a:solidFill>
-                <a:latin typeface="Inter"/>
-              </a:defRPr>
-            </a:pPr>
-            <a:r>
-              <a:t>250kW Solar Grid Optimization</a:t>
-            </a:r>
-          </a:p>
-        </p:txBody>
-      </p:sp>
-      <p:sp>
-        <p:nvSpPr>
-          <p:cNvPr id="5" name="Rounded Rectangle 4"/>
-          <p:cNvSpPr/>
-          <p:nvPr/>
-        </p:nvSpPr>
-        <p:spPr>
-          <a:xfrm>
-            <a:off x="6126480" y="1645920"/>
-            <a:ext cx="2468880" cy="4389120"/>
-          </a:xfrm>
-          <a:prstGeom prst="roundRect">
-            <a:avLst/>
-          </a:prstGeom>
-          <a:solidFill>
-            <a:srgbClr val="0E2A1F"/>
-          </a:solidFill>
-          <a:ln w="19050">
-            <a:solidFill>
-              <a:srgbClr val="00FF66"/>
-            </a:solidFill>
-          </a:ln>
-        </p:spPr>
-        <p:style>
-          <a:lnRef idx="1">
-            <a:schemeClr val="accent1"/>
-          </a:lnRef>
-          <a:fillRef idx="3">
-            <a:schemeClr val="accent1"/>
-          </a:fillRef>
-          <a:effectRef idx="2">
-            <a:schemeClr val="accent1"/>
-          </a:effectRef>
-          <a:fontRef idx="minor">
-            <a:schemeClr val="lt1"/>
-          </a:fontRef>
-        </p:style>
-        <p:txBody>
-          <a:bodyPr rtlCol="0" anchor="ctr" wrap="square" lIns="182880" tIns="182880"/>
-          <a:lstStyle/>
-          <a:p>
-            <a:pPr algn="ctr">
-              <a:defRPr sz="4000" b="1">
-                <a:solidFill>
-                  <a:srgbClr val="00FF66"/>
-                </a:solidFill>
-                <a:latin typeface="Montserrat"/>
-              </a:defRPr>
-            </a:pPr>
-            <a:r>
-              <a:t>50%</a:t>
-            </a:r>
-          </a:p>
-          <a:p>
-            <a:pPr>
-              <a:spcBef>
-                <a:spcPts val="1000"/>
-              </a:spcBef>
-              <a:defRPr sz="1600" b="1">
-                <a:solidFill>
-                  <a:srgbClr val="FFFFFF"/>
-                </a:solidFill>
-                <a:latin typeface="Poppins"/>
-              </a:defRPr>
-            </a:pPr>
-            <a:r>
-              <a:t>Better Waste</a:t>
-            </a:r>
-          </a:p>
-          <a:p>
-            <a:pPr>
-              <a:spcBef>
-                <a:spcPts val="1400"/>
-              </a:spcBef>
-              <a:defRPr sz="1100">
-                <a:solidFill>
-                  <a:srgbClr val="B2DFDB"/>
-                </a:solidFill>
-                <a:latin typeface="Inter"/>
-              </a:defRPr>
-            </a:pPr>
-            <a:r>
-              <a:t>Smart Bin Overflow Prevention</a:t>
-            </a:r>
-          </a:p>
-        </p:txBody>
-      </p:sp>
-      <p:sp>
-        <p:nvSpPr>
-          <p:cNvPr id="6" name="Rounded Rectangle 5"/>
-          <p:cNvSpPr/>
-          <p:nvPr/>
-        </p:nvSpPr>
-        <p:spPr>
-          <a:xfrm>
-            <a:off x="8823960" y="1645920"/>
-            <a:ext cx="2468880" cy="4389120"/>
-          </a:xfrm>
-          <a:prstGeom prst="roundRect">
-            <a:avLst/>
-          </a:prstGeom>
-          <a:solidFill>
-            <a:srgbClr val="0E2A1F"/>
-          </a:solidFill>
-          <a:ln w="19050">
-            <a:solidFill>
-              <a:srgbClr val="00FF66"/>
-            </a:solidFill>
-          </a:ln>
-        </p:spPr>
-        <p:style>
-          <a:lnRef idx="1">
-            <a:schemeClr val="accent1"/>
-          </a:lnRef>
-          <a:fillRef idx="3">
-            <a:schemeClr val="accent1"/>
-          </a:fillRef>
-          <a:effectRef idx="2">
-            <a:schemeClr val="accent1"/>
-          </a:effectRef>
-          <a:fontRef idx="minor">
-            <a:schemeClr val="lt1"/>
-          </a:fontRef>
-        </p:style>
-        <p:txBody>
-          <a:bodyPr rtlCol="0" anchor="ctr" wrap="square" lIns="182880" tIns="182880"/>
-          <a:lstStyle/>
-          <a:p>
-            <a:pPr algn="ctr">
-              <a:defRPr sz="4000" b="1">
-                <a:solidFill>
-                  <a:srgbClr val="00FF66"/>
-                </a:solidFill>
-                <a:latin typeface="Montserrat"/>
-              </a:defRPr>
-            </a:pPr>
-            <a:r>
-              <a:t>90%</a:t>
-            </a:r>
-          </a:p>
-          <a:p>
-            <a:pPr>
-              <a:spcBef>
-                <a:spcPts val="1000"/>
-              </a:spcBef>
-              <a:defRPr sz="1600" b="1">
-                <a:solidFill>
-                  <a:srgbClr val="FFFFFF"/>
-                </a:solidFill>
-                <a:latin typeface="Poppins"/>
-              </a:defRPr>
-            </a:pPr>
-            <a:r>
-              <a:t>Faster Resolution</a:t>
-            </a:r>
-          </a:p>
-          <a:p>
-            <a:pPr>
-              <a:spcBef>
-                <a:spcPts val="1400"/>
-              </a:spcBef>
-              <a:defRPr sz="1100">
-                <a:solidFill>
-                  <a:srgbClr val="B2DFDB"/>
-                </a:solidFill>
-                <a:latin typeface="Inter"/>
-              </a:defRPr>
-            </a:pPr>
-            <a:r>
-              <a:t>Automated GIS Technician Dispatch</a:t>
+              </a:defRPr>
+            </a:pPr>
+            <a:r>
+              <a:t>🌐 Live Site: https://green-verse-ai-smart-campus-sustain.vercel.app</a:t>
+            </a:r>
+            <a:br/>
+            <a:r>
+              <a:t>💻 GitHub: https://github.com/yashkumar5224/GreenVerse-AI-Smart-Campus-Sustainability-Maintenance-Platform.git</a:t>
+            </a:r>
+            <a:br/>
+            <a:r>
+              <a:t>👥 Team: Yash Kumar • Neha Kumari • Suraj Kumar • Utkarsh Raj</a:t>
             </a:r>
           </a:p>
         </p:txBody>

</xml_diff>